<commit_message>
Presentación: diapositiva de cierre y novedades de la versión 1.1
Co-Authored-By: Claude Opus 5.5 <noreply@anthropic.com>
</commit_message>
<xml_diff>
--- a/presentacion/mando.pptx
+++ b/presentacion/mando.pptx
@@ -19,9 +19,10 @@
     <p:sldId id="267" r:id="rId13"/>
     <p:sldId id="268" r:id="rId14"/>
     <p:sldId id="269" r:id="rId15"/>
+    <p:sldId id="270" r:id="rId16"/>
   </p:sldIdLst>
   <p:notesMasterIdLst>
-    <p:notesMasterId r:id="rId16"/>
+    <p:notesMasterId r:id="rId17"/>
   </p:notesMasterIdLst>
   <p:sldSz cx="12192000" cy="6858000"/>
   <p:notesSz cx="6858000" cy="12192000"/>
@@ -120,7 +121,7 @@
   <p:extLst>
     <p:ext uri="{521415D9-36F7-43E2-AB2F-B90AF26B5E84}">
       <p14:sectionLst xmlns:p14="http://schemas.microsoft.com/office/powerpoint/2010/main">
-        <p14:section name="Introducción" id="{5c25ac77-7568-d370-7954-3341fb984dbc}">
+        <p14:section name="Introducción" id="{06db4df0-0b89-3d8a-8a21-2f684eb23efb}">
           <p14:sldIdLst>
             <p14:sldId id="256"/>
             <p14:sldId id="257"/>
@@ -128,30 +129,31 @@
             <p14:sldId id="259"/>
           </p14:sldIdLst>
         </p14:section>
-        <p14:section name="Funciones" id="{0ca03b19-8774-d9e2-38a4-4e37c98ba6a2}">
+        <p14:section name="Funciones" id="{c196b939-49c5-fca3-f3e2-cad589d2b8c8}">
           <p14:sldIdLst>
             <p14:sldId id="260"/>
             <p14:sldId id="261"/>
             <p14:sldId id="262"/>
           </p14:sldIdLst>
         </p14:section>
-        <p14:section name="Valor" id="{480b05e0-8dea-014e-bf79-174b6c827c50}">
+        <p14:section name="Valor" id="{552fc145-2c25-bfea-19c9-1c515cfce813}">
           <p14:sldIdLst>
             <p14:sldId id="263"/>
             <p14:sldId id="264"/>
           </p14:sldIdLst>
         </p14:section>
-        <p14:section name="Tecnología" id="{81db7a37-642f-0e7d-2d7a-03639b6b71a9}">
+        <p14:section name="Tecnología" id="{dcec37d4-004a-6025-fbc3-056e0e3a43af}">
           <p14:sldIdLst>
             <p14:sldId id="265"/>
             <p14:sldId id="266"/>
             <p14:sldId id="267"/>
           </p14:sldIdLst>
         </p14:section>
-        <p14:section name="Cierre" id="{9c22b923-ec6e-2c16-4db9-c040ef75aea6}">
+        <p14:section name="Cierre" id="{c957a61e-37c1-aac5-90f1-28f1f74aab92}">
           <p14:sldIdLst>
             <p14:sldId id="268"/>
             <p14:sldId id="269"/>
+            <p14:sldId id="270"/>
           </p14:sldIdLst>
         </p14:section>
       </p14:sectionLst>
@@ -646,7 +648,7 @@
           <a:p>
             <a:r>
               <a:rPr lang="en-US" dirty="0"/>
-              <a:t>El celular y la computadora se comunican de forma directa mediante WebRTC, cifrado de punto a punto. Un servidor de señalización gratuito solo se usa para que los dos dispositivos se encuentren; después ya no participa. La clave secreta viaja dentro del QR y nunca se envía al servidor.</a:t>
+              <a:t>El celular y la computadora se comunican de forma directa mediante WebRTC, cifrado de punto a punto. Un servidor de señalización gratuito solo se usa para que los dos dispositivos se encuentren; después ya no participa. Si la red bloquea la conexión directa, el tráfico, todavía cifrado, pasa por el servidor de retransmisión de Cloudflare. La clave secreta viaja dentro del QR y nunca se envía al servidor.</a:t>
             </a:r>
             <a:endParaRPr lang="en-US" dirty="0"/>
           </a:p>
@@ -822,7 +824,7 @@
           <a:p>
             <a:r>
               <a:rPr lang="en-US" dirty="0"/>
-              <a:t>Mando se probó de punta a punta con pruebas automáticas que conectan la extensión y el celular de verdad: 38 de 38 comprobaciones superadas. La interfaz se revisó en 28 combinaciones de pantalla y vista. Si se corta el servidor, se reconecta solo en unos 3 segundos sin desconectar al celular.</a:t>
+              <a:t>Mando se probó de punta a punta con pruebas automáticas que conectan la extensión y el celular de verdad: 42 de 42 comprobaciones superadas. La interfaz se revisó en 28 combinaciones de pantalla y vista. Si se corta el servidor, se reconecta solo en unos 3 segundos sin desconectar al celular.</a:t>
             </a:r>
             <a:endParaRPr lang="en-US" dirty="0"/>
           </a:p>
@@ -910,7 +912,7 @@
           <a:p>
             <a:r>
               <a:rPr lang="en-US" dirty="0"/>
-              <a:t>Hoy hay tres límites conocidos: redes muy restrictivas que bloquean la conexión directa, páginas internas de Chrome donde las extensiones no pueden actuar, y programas fuera del navegador. Los próximos pasos son publicar en la Chrome Web Store, sumar un servidor de retransmisión con Cloudflare, ofrecer un QR nuevo por sesión y evaluar una app para Apple Watch.</a:t>
+              <a:t>Hoy hay tres límites conocidos: se necesita internet para enlazar los dispositivos, Chrome no permite extensiones en sus páginas internas, y Mando no controla programas fuera del navegador. Ya están listos la retransmisión con Cloudflare para redes restrictivas y el QR nuevo en cada sesión. La versión 1.0 está en revisión en la Chrome Web Store y la 1.1 está preparada; queda por evaluar una app para Apple Watch.</a:t>
             </a:r>
             <a:endParaRPr lang="en-US" dirty="0"/>
           </a:p>
@@ -1040,6 +1042,94 @@
 </p:notes>
 </file>
 
+<file path=ppt/notesSlides/notesSlide15.xml><?xml version="1.0" encoding="utf-8"?>
+<p:notes xmlns:a="http://schemas.openxmlformats.org/drawingml/2006/main" xmlns:r="http://schemas.openxmlformats.org/officeDocument/2006/relationships" xmlns:p="http://schemas.openxmlformats.org/presentationml/2006/main">
+  <p:cSld>
+    <p:spTree>
+      <p:nvGrpSpPr>
+        <p:cNvPr id="1" name=""/>
+        <p:cNvGrpSpPr/>
+        <p:nvPr/>
+      </p:nvGrpSpPr>
+      <p:grpSpPr>
+        <a:xfrm>
+          <a:off x="0" y="0"/>
+          <a:ext cx="0" cy="0"/>
+          <a:chOff x="0" y="0"/>
+          <a:chExt cx="0" cy="0"/>
+        </a:xfrm>
+      </p:grpSpPr>
+      <p:sp>
+        <p:nvSpPr>
+          <p:cNvPr id="2" name="Slide Image Placeholder 1"/>
+          <p:cNvSpPr>
+            <a:spLocks noGrp="1" noRot="1" noChangeAspect="1"/>
+          </p:cNvSpPr>
+          <p:nvPr>
+            <p:ph type="sldImg"/>
+          </p:nvPr>
+        </p:nvSpPr>
+        <p:spPr/>
+      </p:sp>
+      <p:sp>
+        <p:nvSpPr>
+          <p:cNvPr id="3" name="Notes Placeholder 2"/>
+          <p:cNvSpPr>
+            <a:spLocks noGrp="1"/>
+          </p:cNvSpPr>
+          <p:nvPr>
+            <p:ph type="body" idx="1"/>
+          </p:nvPr>
+        </p:nvSpPr>
+        <p:spPr/>
+        <p:txBody>
+          <a:bodyPr/>
+          <a:lstStyle/>
+          <a:p>
+            <a:r>
+              <a:rPr lang="en-US" dirty="0"/>
+              <a:t>Cierre: agradecer al público y abrir el espacio de preguntas. Si alguien quiere probarlo, puede escanear el código de la diapositiva anterior para ver el proyecto en GitHub.</a:t>
+            </a:r>
+            <a:endParaRPr lang="en-US" dirty="0"/>
+          </a:p>
+        </p:txBody>
+      </p:sp>
+      <p:sp>
+        <p:nvSpPr>
+          <p:cNvPr id="4" name="Slide Number Placeholder 3"/>
+          <p:cNvSpPr>
+            <a:spLocks noGrp="1"/>
+          </p:cNvSpPr>
+          <p:nvPr>
+            <p:ph type="sldNum" sz="quarter" idx="10"/>
+          </p:nvPr>
+        </p:nvSpPr>
+        <p:spPr/>
+        <p:txBody>
+          <a:bodyPr/>
+          <a:lstStyle/>
+          <a:p>
+            <a:fld id="{F7021451-1387-4CA6-816F-3879F97B5CBC}" type="slidenum">
+              <a:rPr lang="en-US"/>
+              <a:t>15</a:t>
+            </a:fld>
+            <a:endParaRPr lang="en-US"/>
+          </a:p>
+        </p:txBody>
+      </p:sp>
+    </p:spTree>
+    <p:extLst>
+      <p:ext uri="{BB962C8B-B14F-4D97-AF65-F5344CB8AC3E}">
+        <p14:creationId xmlns:p14="http://schemas.microsoft.com/office/powerpoint/2010/main" val="1024086991"/>
+      </p:ext>
+    </p:extLst>
+  </p:cSld>
+  <p:clrMapOvr>
+    <a:masterClrMapping/>
+  </p:clrMapOvr>
+</p:notes>
+</file>
+
 <file path=ppt/notesSlides/notesSlide2.xml><?xml version="1.0" encoding="utf-8"?>
 <p:notes xmlns:a="http://schemas.openxmlformats.org/drawingml/2006/main" xmlns:r="http://schemas.openxmlformats.org/officeDocument/2006/relationships" xmlns:p="http://schemas.openxmlformats.org/presentationml/2006/main">
   <p:cSld>
@@ -1262,7 +1352,7 @@
           <a:p>
             <a:r>
               <a:rPr lang="en-US" dirty="0"/>
-              <a:t>Paso 1: abrir la presentación en Chrome. Paso 2: hacer clic en el ícono de Mando o pulsar Alt+Shift+M y escanear el QR con la cámara. Paso 3: presentar desde el celular. El celular recuerda la conexión y se reconecta solo la próxima vez.</a:t>
+              <a:t>Paso 1: abrir la presentación en Chrome. Paso 2: hacer clic en el ícono de Mando o pulsar Alt+Shift+M y escanear el QR con la cámara. Paso 3: presentar desde el celular. Por seguridad, cada sesión genera un código QR nuevo.</a:t>
             </a:r>
             <a:endParaRPr lang="en-US" dirty="0"/>
           </a:p>
@@ -1820,7 +1910,7 @@
         <p:txBody>
           <a:bodyPr wrap="square" rtlCol="0"/>
           <a:lstStyle>
-            <a:lvl1pPr indent="0" marL="0">
+            <a:lvl1pPr algn="l" indent="0" marL="0">
               <a:buNone/>
               <a:defRPr lang="en-US" sz="6600" b="1" dirty="0">
                 <a:solidFill>
@@ -1830,7 +1920,7 @@
             </a:lvl1pPr>
           </a:lstStyle>
           <a:p>
-            <a:pPr indent="0" marL="0">
+            <a:pPr algn="l" indent="0" marL="0">
               <a:buNone/>
             </a:pPr>
             <a:endParaRPr lang="en-US" sz="6600" dirty="0"/>
@@ -1848,7 +1938,7 @@
         <p:spPr>
           <a:xfrm>
             <a:off x="822960" y="3977640"/>
-            <a:ext cx="4754880" cy="914400"/>
+            <a:ext cx="5120640" cy="914400"/>
           </a:xfrm>
           <a:prstGeom prst="rect">
             <a:avLst/>
@@ -1859,9 +1949,9 @@
         <p:txBody>
           <a:bodyPr wrap="square" rtlCol="0"/>
           <a:lstStyle>
-            <a:lvl1pPr indent="0" marL="0">
-              <a:buNone/>
-              <a:defRPr lang="en-US" sz="2200" dirty="0">
+            <a:lvl1pPr algn="l" indent="0" marL="0">
+              <a:buNone/>
+              <a:defRPr lang="en-US" sz="2000" dirty="0">
                 <a:solidFill>
                   <a:schemeClr val="accent5"/>
                 </a:solidFill>
@@ -1869,10 +1959,10 @@
             </a:lvl1pPr>
           </a:lstStyle>
           <a:p>
-            <a:pPr indent="0" marL="0">
-              <a:buNone/>
-            </a:pPr>
-            <a:endParaRPr lang="en-US" sz="2200" dirty="0"/>
+            <a:pPr algn="l" indent="0" marL="0">
+              <a:buNone/>
+            </a:pPr>
+            <a:endParaRPr lang="en-US" sz="2000" dirty="0"/>
           </a:p>
         </p:txBody>
       </p:sp>
@@ -1898,7 +1988,7 @@
         <p:txBody>
           <a:bodyPr wrap="square" rtlCol="0"/>
           <a:lstStyle>
-            <a:lvl1pPr indent="0" marL="0">
+            <a:lvl1pPr algn="l" indent="0" marL="0">
               <a:buNone/>
               <a:defRPr lang="en-US" sz="1200" dirty="0">
                 <a:solidFill>
@@ -1908,7 +1998,7 @@
             </a:lvl1pPr>
           </a:lstStyle>
           <a:p>
-            <a:pPr indent="0" marL="0">
+            <a:pPr algn="l" indent="0" marL="0">
               <a:buNone/>
             </a:pPr>
             <a:endParaRPr lang="en-US" sz="1200" dirty="0"/>
@@ -1969,7 +2059,7 @@
         <p:txBody>
           <a:bodyPr wrap="square" rtlCol="0"/>
           <a:lstStyle>
-            <a:lvl1pPr indent="0" marL="0">
+            <a:lvl1pPr algn="l" indent="0" marL="0">
               <a:buNone/>
               <a:defRPr lang="en-US" sz="1200" b="1" spc="200" kern="0" dirty="0">
                 <a:solidFill>
@@ -1979,7 +2069,7 @@
             </a:lvl1pPr>
           </a:lstStyle>
           <a:p>
-            <a:pPr indent="0" marL="0">
+            <a:pPr algn="l" indent="0" marL="0">
               <a:buNone/>
             </a:pPr>
             <a:endParaRPr lang="en-US" sz="1200" dirty="0"/>
@@ -2008,7 +2098,7 @@
         <p:txBody>
           <a:bodyPr wrap="square" rtlCol="0"/>
           <a:lstStyle>
-            <a:lvl1pPr indent="0" marL="0">
+            <a:lvl1pPr algn="l" indent="0" marL="0">
               <a:buNone/>
               <a:defRPr lang="en-US" sz="3600" b="1" dirty="0">
                 <a:solidFill>
@@ -2018,7 +2108,7 @@
             </a:lvl1pPr>
           </a:lstStyle>
           <a:p>
-            <a:pPr indent="0" marL="0">
+            <a:pPr algn="l" indent="0" marL="0">
               <a:buNone/>
             </a:pPr>
             <a:endParaRPr lang="en-US" sz="3600" dirty="0"/>
@@ -2160,7 +2250,7 @@
         <p:txBody>
           <a:bodyPr wrap="square" rtlCol="0"/>
           <a:lstStyle>
-            <a:lvl1pPr indent="0" marL="0">
+            <a:lvl1pPr algn="l" indent="0" marL="0">
               <a:buNone/>
               <a:defRPr lang="en-US" sz="1200" b="1" spc="200" kern="0" dirty="0">
                 <a:solidFill>
@@ -2170,7 +2260,7 @@
             </a:lvl1pPr>
           </a:lstStyle>
           <a:p>
-            <a:pPr indent="0" marL="0">
+            <a:pPr algn="l" indent="0" marL="0">
               <a:buNone/>
             </a:pPr>
             <a:endParaRPr lang="en-US" sz="1200" dirty="0"/>
@@ -2199,7 +2289,7 @@
         <p:txBody>
           <a:bodyPr wrap="square" rtlCol="0"/>
           <a:lstStyle>
-            <a:lvl1pPr indent="0" marL="0">
+            <a:lvl1pPr algn="l" indent="0" marL="0">
               <a:buNone/>
               <a:defRPr lang="en-US" sz="3600" b="1" dirty="0">
                 <a:solidFill>
@@ -2209,7 +2299,7 @@
             </a:lvl1pPr>
           </a:lstStyle>
           <a:p>
-            <a:pPr indent="0" marL="0">
+            <a:pPr algn="l" indent="0" marL="0">
               <a:buNone/>
             </a:pPr>
             <a:endParaRPr lang="en-US" sz="3600" dirty="0"/>
@@ -2351,7 +2441,7 @@
         <p:txBody>
           <a:bodyPr wrap="square" rtlCol="0"/>
           <a:lstStyle>
-            <a:lvl1pPr indent="0" marL="0">
+            <a:lvl1pPr algn="l" indent="0" marL="0">
               <a:buNone/>
               <a:defRPr lang="en-US" sz="5200" b="1" dirty="0">
                 <a:solidFill>
@@ -2361,7 +2451,7 @@
             </a:lvl1pPr>
           </a:lstStyle>
           <a:p>
-            <a:pPr indent="0" marL="0">
+            <a:pPr algn="l" indent="0" marL="0">
               <a:buNone/>
             </a:pPr>
             <a:endParaRPr lang="en-US" sz="5200" dirty="0"/>
@@ -2390,7 +2480,7 @@
         <p:txBody>
           <a:bodyPr wrap="square" rtlCol="0"/>
           <a:lstStyle>
-            <a:lvl1pPr indent="0" marL="0">
+            <a:lvl1pPr algn="l" indent="0" marL="0">
               <a:buNone/>
               <a:defRPr lang="en-US" sz="2000" dirty="0">
                 <a:solidFill>
@@ -2400,7 +2490,7 @@
             </a:lvl1pPr>
           </a:lstStyle>
           <a:p>
-            <a:pPr indent="0" marL="0">
+            <a:pPr algn="l" indent="0" marL="0">
               <a:buNone/>
             </a:pPr>
             <a:endParaRPr lang="en-US" sz="2000" dirty="0"/>
@@ -2805,7 +2895,7 @@
           <a:bodyPr wrap="square" lIns="0" tIns="0" rIns="0" bIns="0" rtlCol="0" anchor="b"/>
           <a:lstStyle/>
           <a:p>
-            <a:pPr indent="0" marL="0">
+            <a:pPr algn="l" indent="0" marL="0">
               <a:buNone/>
             </a:pPr>
             <a:r>
@@ -2831,7 +2921,7 @@
         <p:spPr>
           <a:xfrm>
             <a:off x="822960" y="3977640"/>
-            <a:ext cx="4754880" cy="914400"/>
+            <a:ext cx="5120640" cy="914400"/>
           </a:xfrm>
           <a:prstGeom prst="rect">
             <a:avLst/>
@@ -2843,18 +2933,18 @@
           <a:bodyPr wrap="square" lIns="0" tIns="0" rIns="0" bIns="0" rtlCol="0" anchor="t"/>
           <a:lstStyle/>
           <a:p>
-            <a:pPr indent="0" marL="0">
-              <a:buNone/>
-            </a:pPr>
-            <a:r>
-              <a:rPr lang="en-US" sz="2200" dirty="0">
+            <a:pPr algn="l" indent="0" marL="0">
+              <a:buNone/>
+            </a:pPr>
+            <a:r>
+              <a:rPr lang="en-US" sz="2000" dirty="0">
                 <a:solidFill>
                   <a:schemeClr val="accent5"/>
                 </a:solidFill>
               </a:rPr>
               <a:t>Controla tus presentaciones desde el celular</a:t>
             </a:r>
-            <a:endParaRPr lang="en-US" sz="2200" dirty="0"/>
+            <a:endParaRPr lang="en-US" sz="2000" dirty="0"/>
           </a:p>
         </p:txBody>
       </p:sp>
@@ -2881,7 +2971,7 @@
           <a:bodyPr wrap="square" lIns="0" tIns="0" rIns="0" bIns="0" rtlCol="0" anchor="ctr"/>
           <a:lstStyle/>
           <a:p>
-            <a:pPr indent="0" marL="0">
+            <a:pPr algn="l" indent="0" marL="0">
               <a:buNone/>
             </a:pPr>
             <a:r>
@@ -3017,7 +3107,7 @@
           <a:bodyPr wrap="square" lIns="0" tIns="0" rIns="0" bIns="0" rtlCol="0" anchor="ctr"/>
           <a:lstStyle/>
           <a:p>
-            <a:pPr indent="0" marL="0">
+            <a:pPr algn="l" indent="0" marL="0">
               <a:buNone/>
             </a:pPr>
             <a:r>
@@ -3055,7 +3145,7 @@
           <a:bodyPr wrap="square" lIns="0" tIns="0" rIns="0" bIns="0" rtlCol="0" anchor="t"/>
           <a:lstStyle/>
           <a:p>
-            <a:pPr indent="0" marL="0">
+            <a:pPr algn="l" indent="0" marL="0">
               <a:buNone/>
             </a:pPr>
             <a:r>
@@ -3064,7 +3154,7 @@
                   <a:schemeClr val="tx1"/>
                 </a:solidFill>
               </a:rPr>
-              <a:t>Conexión directa entre tu celular y tu computadora</a:t>
+              <a:t>Una conexión directa y cifrada</a:t>
             </a:r>
             <a:endParaRPr lang="en-US" sz="3600" dirty="0"/>
           </a:p>
@@ -3072,7 +3162,7 @@
       </p:sp>
       <p:sp>
         <p:nvSpPr>
-          <p:cNvPr id="4" name="tarjeta-142"/>
+          <p:cNvPr id="4" name="tarjeta-143"/>
           <p:cNvSpPr/>
           <p:nvPr/>
         </p:nvSpPr>
@@ -3094,7 +3184,7 @@
       </p:sp>
       <p:sp>
         <p:nvSpPr>
-          <p:cNvPr id="5" name="icono-fondo-143"/>
+          <p:cNvPr id="5" name="icono-fondo-144"/>
           <p:cNvSpPr/>
           <p:nvPr/>
         </p:nvSpPr>
@@ -3116,7 +3206,7 @@
       </p:sp>
       <p:pic>
         <p:nvPicPr>
-          <p:cNvPr id="6" name="icono-LuServer-144" descr="preencoded.png">    </p:cNvPr>
+          <p:cNvPr id="6" name="icono-LuServer-145" descr="preencoded.png">    </p:cNvPr>
           <p:cNvPicPr>
             <a:picLocks noChangeAspect="1"/>
           </p:cNvPicPr>
@@ -3140,7 +3230,7 @@
       </p:pic>
       <p:sp>
         <p:nvSpPr>
-          <p:cNvPr id="7" name="texto-145"/>
+          <p:cNvPr id="7" name="texto-146"/>
           <p:cNvSpPr txBox="1"/>
           <p:nvPr/>
         </p:nvSpPr>
@@ -3285,7 +3375,7 @@
       </p:sp>
       <p:sp>
         <p:nvSpPr>
-          <p:cNvPr id="12" name="tarjeta-146"/>
+          <p:cNvPr id="12" name="tarjeta-147"/>
           <p:cNvSpPr/>
           <p:nvPr/>
         </p:nvSpPr>
@@ -3307,7 +3397,7 @@
       </p:sp>
       <p:sp>
         <p:nvSpPr>
-          <p:cNvPr id="13" name="icono-fondo-147"/>
+          <p:cNvPr id="13" name="icono-fondo-148"/>
           <p:cNvSpPr/>
           <p:nvPr/>
         </p:nvSpPr>
@@ -3329,7 +3419,7 @@
       </p:sp>
       <p:pic>
         <p:nvPicPr>
-          <p:cNvPr id="14" name="icono-LuSmartphone-148" descr="preencoded.png">    </p:cNvPr>
+          <p:cNvPr id="14" name="icono-LuSmartphone-149" descr="preencoded.png">    </p:cNvPr>
           <p:cNvPicPr>
             <a:picLocks noChangeAspect="1"/>
           </p:cNvPicPr>
@@ -3353,7 +3443,7 @@
       </p:pic>
       <p:sp>
         <p:nvSpPr>
-          <p:cNvPr id="15" name="texto-149"/>
+          <p:cNvPr id="15" name="texto-150"/>
           <p:cNvSpPr txBox="1"/>
           <p:nvPr/>
         </p:nvSpPr>
@@ -3406,7 +3496,7 @@
       </p:sp>
       <p:sp>
         <p:nvSpPr>
-          <p:cNvPr id="16" name="tarjeta-150"/>
+          <p:cNvPr id="16" name="tarjeta-151"/>
           <p:cNvSpPr/>
           <p:nvPr/>
         </p:nvSpPr>
@@ -3428,7 +3518,7 @@
       </p:sp>
       <p:sp>
         <p:nvSpPr>
-          <p:cNvPr id="17" name="icono-fondo-151"/>
+          <p:cNvPr id="17" name="icono-fondo-152"/>
           <p:cNvSpPr/>
           <p:nvPr/>
         </p:nvSpPr>
@@ -3450,7 +3540,7 @@
       </p:sp>
       <p:pic>
         <p:nvPicPr>
-          <p:cNvPr id="18" name="icono-LuLaptop-152" descr="preencoded.png">    </p:cNvPr>
+          <p:cNvPr id="18" name="icono-LuLaptop-153" descr="preencoded.png">    </p:cNvPr>
           <p:cNvPicPr>
             <a:picLocks noChangeAspect="1"/>
           </p:cNvPicPr>
@@ -3474,7 +3564,7 @@
       </p:pic>
       <p:sp>
         <p:nvSpPr>
-          <p:cNvPr id="19" name="texto-153"/>
+          <p:cNvPr id="19" name="texto-154"/>
           <p:cNvSpPr txBox="1"/>
           <p:nvPr/>
         </p:nvSpPr>
@@ -3594,7 +3684,7 @@
                   <a:schemeClr val="accent6"/>
                 </a:solidFill>
               </a:rPr>
-              <a:t>Avanzar, láser, mouse y texto</a:t>
+              <a:t>Si la red lo bloquea, pasa cifrado por Cloudflare</a:t>
             </a:r>
             <a:endParaRPr lang="en-US" sz="1500" dirty="0"/>
           </a:p>
@@ -3602,7 +3692,7 @@
       </p:sp>
       <p:sp>
         <p:nvSpPr>
-          <p:cNvPr id="22" name="paso-154"/>
+          <p:cNvPr id="22" name="paso-155"/>
           <p:cNvSpPr/>
           <p:nvPr/>
         </p:nvSpPr>
@@ -3622,7 +3712,7 @@
       </p:sp>
       <p:sp>
         <p:nvSpPr>
-          <p:cNvPr id="23" name="paso-n-155"/>
+          <p:cNvPr id="23" name="paso-n-156"/>
           <p:cNvSpPr txBox="1"/>
           <p:nvPr/>
         </p:nvSpPr>
@@ -3658,7 +3748,7 @@
       </p:sp>
       <p:sp>
         <p:nvSpPr>
-          <p:cNvPr id="24" name="paso-texto-156"/>
+          <p:cNvPr id="24" name="paso-texto-157"/>
           <p:cNvSpPr txBox="1"/>
           <p:nvPr/>
         </p:nvSpPr>
@@ -3694,7 +3784,7 @@
       </p:sp>
       <p:sp>
         <p:nvSpPr>
-          <p:cNvPr id="25" name="paso-157"/>
+          <p:cNvPr id="25" name="paso-158"/>
           <p:cNvSpPr/>
           <p:nvPr/>
         </p:nvSpPr>
@@ -3714,7 +3804,7 @@
       </p:sp>
       <p:sp>
         <p:nvSpPr>
-          <p:cNvPr id="26" name="paso-n-158"/>
+          <p:cNvPr id="26" name="paso-n-159"/>
           <p:cNvSpPr txBox="1"/>
           <p:nvPr/>
         </p:nvSpPr>
@@ -3750,7 +3840,7 @@
       </p:sp>
       <p:sp>
         <p:nvSpPr>
-          <p:cNvPr id="27" name="paso-texto-159"/>
+          <p:cNvPr id="27" name="paso-texto-160"/>
           <p:cNvSpPr txBox="1"/>
           <p:nvPr/>
         </p:nvSpPr>
@@ -3786,7 +3876,7 @@
       </p:sp>
       <p:sp>
         <p:nvSpPr>
-          <p:cNvPr id="28" name="paso-160"/>
+          <p:cNvPr id="28" name="paso-161"/>
           <p:cNvSpPr/>
           <p:nvPr/>
         </p:nvSpPr>
@@ -3806,7 +3896,7 @@
       </p:sp>
       <p:sp>
         <p:nvSpPr>
-          <p:cNvPr id="29" name="paso-n-161"/>
+          <p:cNvPr id="29" name="paso-n-162"/>
           <p:cNvSpPr txBox="1"/>
           <p:nvPr/>
         </p:nvSpPr>
@@ -3842,7 +3932,7 @@
       </p:sp>
       <p:sp>
         <p:nvSpPr>
-          <p:cNvPr id="30" name="paso-texto-162"/>
+          <p:cNvPr id="30" name="paso-texto-163"/>
           <p:cNvSpPr txBox="1"/>
           <p:nvPr/>
         </p:nvSpPr>
@@ -3969,7 +4059,7 @@
           <a:bodyPr wrap="square" lIns="0" tIns="0" rIns="0" bIns="0" rtlCol="0" anchor="ctr"/>
           <a:lstStyle/>
           <a:p>
-            <a:pPr indent="0" marL="0">
+            <a:pPr algn="l" indent="0" marL="0">
               <a:buNone/>
             </a:pPr>
             <a:r>
@@ -4007,7 +4097,7 @@
           <a:bodyPr wrap="square" lIns="0" tIns="0" rIns="0" bIns="0" rtlCol="0" anchor="t"/>
           <a:lstStyle/>
           <a:p>
-            <a:pPr indent="0" marL="0">
+            <a:pPr algn="l" indent="0" marL="0">
               <a:buNone/>
             </a:pPr>
             <a:r>
@@ -4024,7 +4114,7 @@
       </p:sp>
       <p:sp>
         <p:nvSpPr>
-          <p:cNvPr id="4" name="icono-fondo-163"/>
+          <p:cNvPr id="4" name="icono-fondo-164"/>
           <p:cNvSpPr/>
           <p:nvPr/>
         </p:nvSpPr>
@@ -4046,7 +4136,7 @@
       </p:sp>
       <p:pic>
         <p:nvPicPr>
-          <p:cNvPr id="5" name="icono-LuLock-164" descr="preencoded.png">    </p:cNvPr>
+          <p:cNvPr id="5" name="icono-LuLock-165" descr="preencoded.png">    </p:cNvPr>
           <p:cNvPicPr>
             <a:picLocks noChangeAspect="1"/>
           </p:cNvPicPr>
@@ -4070,7 +4160,7 @@
       </p:pic>
       <p:sp>
         <p:nvSpPr>
-          <p:cNvPr id="6" name="texto-165"/>
+          <p:cNvPr id="6" name="texto-166"/>
           <p:cNvSpPr txBox="1"/>
           <p:nvPr/>
         </p:nvSpPr>
@@ -4123,7 +4213,7 @@
       </p:sp>
       <p:sp>
         <p:nvSpPr>
-          <p:cNvPr id="7" name="icono-fondo-166"/>
+          <p:cNvPr id="7" name="icono-fondo-167"/>
           <p:cNvSpPr/>
           <p:nvPr/>
         </p:nvSpPr>
@@ -4145,7 +4235,7 @@
       </p:sp>
       <p:pic>
         <p:nvPicPr>
-          <p:cNvPr id="8" name="icono-LuPower-167" descr="preencoded.png">    </p:cNvPr>
+          <p:cNvPr id="8" name="icono-LuPower-168" descr="preencoded.png">    </p:cNvPr>
           <p:cNvPicPr>
             <a:picLocks noChangeAspect="1"/>
           </p:cNvPicPr>
@@ -4169,7 +4259,7 @@
       </p:pic>
       <p:sp>
         <p:nvSpPr>
-          <p:cNvPr id="9" name="texto-168"/>
+          <p:cNvPr id="9" name="texto-169"/>
           <p:cNvSpPr txBox="1"/>
           <p:nvPr/>
         </p:nvSpPr>
@@ -4222,7 +4312,7 @@
       </p:sp>
       <p:sp>
         <p:nvSpPr>
-          <p:cNvPr id="10" name="icono-fondo-169"/>
+          <p:cNvPr id="10" name="icono-fondo-170"/>
           <p:cNvSpPr/>
           <p:nvPr/>
         </p:nvSpPr>
@@ -4244,7 +4334,7 @@
       </p:sp>
       <p:pic>
         <p:nvPicPr>
-          <p:cNvPr id="11" name="icono-LuKeyRound-170" descr="preencoded.png">    </p:cNvPr>
+          <p:cNvPr id="11" name="icono-LuKeyRound-171" descr="preencoded.png">    </p:cNvPr>
           <p:cNvPicPr>
             <a:picLocks noChangeAspect="1"/>
           </p:cNvPicPr>
@@ -4268,7 +4358,7 @@
       </p:pic>
       <p:sp>
         <p:nvSpPr>
-          <p:cNvPr id="12" name="texto-171"/>
+          <p:cNvPr id="12" name="texto-172"/>
           <p:cNvSpPr txBox="1"/>
           <p:nvPr/>
         </p:nvSpPr>
@@ -4321,7 +4411,7 @@
       </p:sp>
       <p:sp>
         <p:nvSpPr>
-          <p:cNvPr id="13" name="icono-fondo-172"/>
+          <p:cNvPr id="13" name="icono-fondo-173"/>
           <p:cNvSpPr/>
           <p:nvPr/>
         </p:nvSpPr>
@@ -4343,7 +4433,7 @@
       </p:sp>
       <p:pic>
         <p:nvPicPr>
-          <p:cNvPr id="14" name="icono-LuEyeOff-173" descr="preencoded.png">    </p:cNvPr>
+          <p:cNvPr id="14" name="icono-LuEyeOff-174" descr="preencoded.png">    </p:cNvPr>
           <p:cNvPicPr>
             <a:picLocks noChangeAspect="1"/>
           </p:cNvPicPr>
@@ -4367,7 +4457,7 @@
       </p:pic>
       <p:sp>
         <p:nvSpPr>
-          <p:cNvPr id="15" name="texto-174"/>
+          <p:cNvPr id="15" name="texto-175"/>
           <p:cNvSpPr txBox="1"/>
           <p:nvPr/>
         </p:nvSpPr>
@@ -4420,7 +4510,7 @@
       </p:sp>
       <p:sp>
         <p:nvSpPr>
-          <p:cNvPr id="16" name="icono-fondo-175"/>
+          <p:cNvPr id="16" name="icono-fondo-176"/>
           <p:cNvSpPr/>
           <p:nvPr/>
         </p:nvSpPr>
@@ -4442,7 +4532,7 @@
       </p:sp>
       <p:pic>
         <p:nvPicPr>
-          <p:cNvPr id="17" name="icono-LuRefreshCw-176" descr="preencoded.png">    </p:cNvPr>
+          <p:cNvPr id="17" name="icono-LuRefreshCw-177" descr="preencoded.png">    </p:cNvPr>
           <p:cNvPicPr>
             <a:picLocks noChangeAspect="1"/>
           </p:cNvPicPr>
@@ -4466,7 +4556,7 @@
       </p:pic>
       <p:sp>
         <p:nvSpPr>
-          <p:cNvPr id="18" name="texto-177"/>
+          <p:cNvPr id="18" name="texto-178"/>
           <p:cNvSpPr txBox="1"/>
           <p:nvPr/>
         </p:nvSpPr>
@@ -4497,7 +4587,7 @@
                   <a:schemeClr val="bg1"/>
                 </a:solidFill>
               </a:rPr>
-              <a:t>Código renovable</a:t>
+              <a:t>Código nuevo en cada sesión</a:t>
             </a:r>
             <a:endParaRPr lang="en-US" sz="1700" dirty="0"/>
           </a:p>
@@ -4511,7 +4601,7 @@
                   <a:schemeClr val="accent5"/>
                 </a:solidFill>
               </a:rPr>
-              <a:t>«Nuevo código» invalida el QR anterior y desconecta a todos.</a:t>
+              <a:t>El QR cambia en cada sesión y puedes renovarlo cuando quieras.</a:t>
             </a:r>
             <a:endParaRPr lang="en-US" sz="1700" dirty="0"/>
           </a:p>
@@ -4519,7 +4609,7 @@
       </p:sp>
       <p:sp>
         <p:nvSpPr>
-          <p:cNvPr id="19" name="icono-fondo-178"/>
+          <p:cNvPr id="19" name="icono-fondo-179"/>
           <p:cNvSpPr/>
           <p:nvPr/>
         </p:nvSpPr>
@@ -4541,7 +4631,7 @@
       </p:sp>
       <p:pic>
         <p:nvPicPr>
-          <p:cNvPr id="20" name="icono-LuGithub-179" descr="preencoded.png">    </p:cNvPr>
+          <p:cNvPr id="20" name="icono-LuGithub-180" descr="preencoded.png">    </p:cNvPr>
           <p:cNvPicPr>
             <a:picLocks noChangeAspect="1"/>
           </p:cNvPicPr>
@@ -4565,7 +4655,7 @@
       </p:pic>
       <p:sp>
         <p:nvSpPr>
-          <p:cNvPr id="21" name="texto-180"/>
+          <p:cNvPr id="21" name="texto-181"/>
           <p:cNvSpPr txBox="1"/>
           <p:nvPr/>
         </p:nvSpPr>
@@ -4709,7 +4799,7 @@
           <a:bodyPr wrap="square" lIns="0" tIns="0" rIns="0" bIns="0" rtlCol="0" anchor="ctr"/>
           <a:lstStyle/>
           <a:p>
-            <a:pPr indent="0" marL="0">
+            <a:pPr algn="l" indent="0" marL="0">
               <a:buNone/>
             </a:pPr>
             <a:r>
@@ -4747,7 +4837,7 @@
           <a:bodyPr wrap="square" lIns="0" tIns="0" rIns="0" bIns="0" rtlCol="0" anchor="t"/>
           <a:lstStyle/>
           <a:p>
-            <a:pPr indent="0" marL="0">
+            <a:pPr algn="l" indent="0" marL="0">
               <a:buNone/>
             </a:pPr>
             <a:r>
@@ -4764,7 +4854,7 @@
       </p:sp>
       <p:sp>
         <p:nvSpPr>
-          <p:cNvPr id="4" name="cifra-181"/>
+          <p:cNvPr id="4" name="cifra-182"/>
           <p:cNvSpPr txBox="1"/>
           <p:nvPr/>
         </p:nvSpPr>
@@ -4795,7 +4885,7 @@
                 <a:ea typeface="Arial" pitchFamily="34" charset="-122"/>
                 <a:cs typeface="Arial" pitchFamily="34" charset="-120"/>
               </a:rPr>
-              <a:t>38/38</a:t>
+              <a:t>42/42</a:t>
             </a:r>
             <a:endParaRPr lang="en-US" sz="5400" dirty="0"/>
           </a:p>
@@ -4803,7 +4893,7 @@
       </p:sp>
       <p:sp>
         <p:nvSpPr>
-          <p:cNvPr id="5" name="texto-182"/>
+          <p:cNvPr id="5" name="texto-183"/>
           <p:cNvSpPr txBox="1"/>
           <p:nvPr/>
         </p:nvSpPr>
@@ -4856,7 +4946,7 @@
       </p:sp>
       <p:sp>
         <p:nvSpPr>
-          <p:cNvPr id="6" name="cifra-183"/>
+          <p:cNvPr id="6" name="cifra-184"/>
           <p:cNvSpPr txBox="1"/>
           <p:nvPr/>
         </p:nvSpPr>
@@ -4895,7 +4985,7 @@
       </p:sp>
       <p:sp>
         <p:nvSpPr>
-          <p:cNvPr id="7" name="texto-184"/>
+          <p:cNvPr id="7" name="texto-185"/>
           <p:cNvSpPr txBox="1"/>
           <p:nvPr/>
         </p:nvSpPr>
@@ -4948,7 +5038,7 @@
       </p:sp>
       <p:sp>
         <p:nvSpPr>
-          <p:cNvPr id="8" name="cifra-185"/>
+          <p:cNvPr id="8" name="cifra-186"/>
           <p:cNvSpPr txBox="1"/>
           <p:nvPr/>
         </p:nvSpPr>
@@ -4987,7 +5077,7 @@
       </p:sp>
       <p:sp>
         <p:nvSpPr>
-          <p:cNvPr id="9" name="texto-186"/>
+          <p:cNvPr id="9" name="texto-187"/>
           <p:cNvSpPr txBox="1"/>
           <p:nvPr/>
         </p:nvSpPr>
@@ -5040,7 +5130,7 @@
       </p:sp>
       <p:sp>
         <p:nvSpPr>
-          <p:cNvPr id="10" name="cifra-187"/>
+          <p:cNvPr id="10" name="cifra-188"/>
           <p:cNvSpPr txBox="1"/>
           <p:nvPr/>
         </p:nvSpPr>
@@ -5079,7 +5169,7 @@
       </p:sp>
       <p:sp>
         <p:nvSpPr>
-          <p:cNvPr id="11" name="texto-188"/>
+          <p:cNvPr id="11" name="texto-189"/>
           <p:cNvSpPr txBox="1"/>
           <p:nvPr/>
         </p:nvSpPr>
@@ -5132,18 +5222,18 @@
       </p:sp>
       <p:sp>
         <p:nvSpPr>
-          <p:cNvPr id="12" name="tarjeta-189"/>
-          <p:cNvSpPr/>
-          <p:nvPr/>
-        </p:nvSpPr>
-        <p:spPr>
-          <a:xfrm>
-            <a:off x="640080" y="4434840"/>
-            <a:ext cx="10911535" cy="1463040"/>
+          <p:cNvPr id="12" name="tarjeta-190"/>
+          <p:cNvSpPr/>
+          <p:nvPr/>
+        </p:nvSpPr>
+        <p:spPr>
+          <a:xfrm>
+            <a:off x="640080" y="4480560"/>
+            <a:ext cx="10911535" cy="1097280"/>
           </a:xfrm>
           <a:prstGeom prst="roundRect">
             <a:avLst>
-              <a:gd name="adj" fmla="val 10000"/>
+              <a:gd name="adj" fmla="val 13333"/>
             </a:avLst>
           </a:prstGeom>
           <a:solidFill>
@@ -5154,7 +5244,7 @@
       </p:sp>
       <p:pic>
         <p:nvPicPr>
-          <p:cNvPr id="13" name="check-190" descr="preencoded.png">    </p:cNvPr>
+          <p:cNvPr id="13" name="check-191" descr="preencoded.png">    </p:cNvPr>
           <p:cNvPicPr>
             <a:picLocks noChangeAspect="1"/>
           </p:cNvPicPr>
@@ -5178,14 +5268,14 @@
       </p:pic>
       <p:sp>
         <p:nvSpPr>
-          <p:cNvPr id="14" name="texto-191"/>
+          <p:cNvPr id="14" name="texto-192"/>
           <p:cNvSpPr txBox="1"/>
           <p:nvPr/>
         </p:nvSpPr>
         <p:spPr>
           <a:xfrm>
             <a:off x="1508760" y="4690872"/>
-            <a:ext cx="4495648" cy="1005840"/>
+            <a:ext cx="4495648" cy="777240"/>
           </a:xfrm>
           <a:prstGeom prst="rect">
             <a:avLst/>
@@ -5231,7 +5321,7 @@
       </p:sp>
       <p:pic>
         <p:nvPicPr>
-          <p:cNvPr id="15" name="check-192" descr="preencoded.png">    </p:cNvPr>
+          <p:cNvPr id="15" name="check-193" descr="preencoded.png">    </p:cNvPr>
           <p:cNvPicPr>
             <a:picLocks noChangeAspect="1"/>
           </p:cNvPicPr>
@@ -5255,14 +5345,14 @@
       </p:pic>
       <p:sp>
         <p:nvSpPr>
-          <p:cNvPr id="16" name="texto-193"/>
+          <p:cNvPr id="16" name="texto-194"/>
           <p:cNvSpPr txBox="1"/>
           <p:nvPr/>
         </p:nvSpPr>
         <p:spPr>
           <a:xfrm>
             <a:off x="6964528" y="4690872"/>
-            <a:ext cx="4495648" cy="1005840"/>
+            <a:ext cx="4495648" cy="777240"/>
           </a:xfrm>
           <a:prstGeom prst="rect">
             <a:avLst/>
@@ -5399,7 +5489,7 @@
           <a:bodyPr wrap="square" lIns="0" tIns="0" rIns="0" bIns="0" rtlCol="0" anchor="ctr"/>
           <a:lstStyle/>
           <a:p>
-            <a:pPr indent="0" marL="0">
+            <a:pPr algn="l" indent="0" marL="0">
               <a:buNone/>
             </a:pPr>
             <a:r>
@@ -5437,7 +5527,7 @@
           <a:bodyPr wrap="square" lIns="0" tIns="0" rIns="0" bIns="0" rtlCol="0" anchor="t"/>
           <a:lstStyle/>
           <a:p>
-            <a:pPr indent="0" marL="0">
+            <a:pPr algn="l" indent="0" marL="0">
               <a:buNone/>
             </a:pPr>
             <a:r>
@@ -5454,7 +5544,7 @@
       </p:sp>
       <p:sp>
         <p:nvSpPr>
-          <p:cNvPr id="4" name="tarjeta-194"/>
+          <p:cNvPr id="4" name="tarjeta-195"/>
           <p:cNvSpPr/>
           <p:nvPr/>
         </p:nvSpPr>
@@ -5476,7 +5566,7 @@
       </p:sp>
       <p:sp>
         <p:nvSpPr>
-          <p:cNvPr id="5" name="icono-fondo-195"/>
+          <p:cNvPr id="5" name="icono-fondo-196"/>
           <p:cNvSpPr/>
           <p:nvPr/>
         </p:nvSpPr>
@@ -5498,7 +5588,7 @@
       </p:sp>
       <p:pic>
         <p:nvPicPr>
-          <p:cNvPr id="6" name="icono-LuTriangleAlert-196" descr="preencoded.png">    </p:cNvPr>
+          <p:cNvPr id="6" name="icono-LuTriangleAlert-197" descr="preencoded.png">    </p:cNvPr>
           <p:cNvPicPr>
             <a:picLocks noChangeAspect="1"/>
           </p:cNvPicPr>
@@ -5558,7 +5648,7 @@
       </p:sp>
       <p:sp>
         <p:nvSpPr>
-          <p:cNvPr id="8" name="punto-197"/>
+          <p:cNvPr id="8" name="punto-198"/>
           <p:cNvSpPr/>
           <p:nvPr/>
         </p:nvSpPr>
@@ -5578,7 +5668,7 @@
       </p:sp>
       <p:sp>
         <p:nvSpPr>
-          <p:cNvPr id="9" name="texto-198"/>
+          <p:cNvPr id="9" name="texto-199"/>
           <p:cNvSpPr txBox="1"/>
           <p:nvPr/>
         </p:nvSpPr>
@@ -5609,7 +5699,7 @@
                   <a:schemeClr val="tx1"/>
                 </a:solidFill>
               </a:rPr>
-              <a:t>Redes muy restrictivas</a:t>
+              <a:t>Necesita internet</a:t>
             </a:r>
             <a:endParaRPr lang="en-US" sz="1600" dirty="0"/>
           </a:p>
@@ -5623,7 +5713,7 @@
                   <a:schemeClr val="accent6"/>
                 </a:solidFill>
               </a:rPr>
-              <a:t>Algunas redes de empresa o Wi-Fi públicos bloquean la conexión directa.</a:t>
+              <a:t>El celular y la computadora se enlazan a través de internet.</a:t>
             </a:r>
             <a:endParaRPr lang="en-US" sz="1600" dirty="0"/>
           </a:p>
@@ -5631,7 +5721,7 @@
       </p:sp>
       <p:sp>
         <p:nvSpPr>
-          <p:cNvPr id="10" name="punto-199"/>
+          <p:cNvPr id="10" name="punto-200"/>
           <p:cNvSpPr/>
           <p:nvPr/>
         </p:nvSpPr>
@@ -5651,7 +5741,7 @@
       </p:sp>
       <p:sp>
         <p:nvSpPr>
-          <p:cNvPr id="11" name="texto-200"/>
+          <p:cNvPr id="11" name="texto-201"/>
           <p:cNvSpPr txBox="1"/>
           <p:nvPr/>
         </p:nvSpPr>
@@ -5704,7 +5794,7 @@
       </p:sp>
       <p:sp>
         <p:nvSpPr>
-          <p:cNvPr id="12" name="punto-201"/>
+          <p:cNvPr id="12" name="punto-202"/>
           <p:cNvSpPr/>
           <p:nvPr/>
         </p:nvSpPr>
@@ -5724,7 +5814,7 @@
       </p:sp>
       <p:sp>
         <p:nvSpPr>
-          <p:cNvPr id="13" name="texto-202"/>
+          <p:cNvPr id="13" name="texto-203"/>
           <p:cNvSpPr txBox="1"/>
           <p:nvPr/>
         </p:nvSpPr>
@@ -5805,7 +5895,7 @@
                   <a:schemeClr val="tx1"/>
                 </a:solidFill>
               </a:rPr>
-              <a:t>Próximos pasos</a:t>
+              <a:t>Avances y próximos pasos</a:t>
             </a:r>
             <a:endParaRPr lang="en-US" sz="1800" dirty="0"/>
           </a:p>
@@ -5813,7 +5903,7 @@
       </p:sp>
       <p:sp>
         <p:nvSpPr>
-          <p:cNvPr id="15" name="icono-fondo-203"/>
+          <p:cNvPr id="15" name="icono-fondo-204"/>
           <p:cNvSpPr/>
           <p:nvPr/>
         </p:nvSpPr>
@@ -5828,14 +5918,14 @@
             </a:avLst>
           </a:prstGeom>
           <a:solidFill>
-            <a:schemeClr val="accent1"/>
+            <a:schemeClr val="accent2"/>
           </a:solidFill>
           <a:ln/>
         </p:spPr>
       </p:sp>
       <p:pic>
         <p:nvPicPr>
-          <p:cNvPr id="16" name="icono-LuRocket-204" descr="preencoded.png">    </p:cNvPr>
+          <p:cNvPr id="16" name="icono-LuCircleCheck-205" descr="preencoded.png">    </p:cNvPr>
           <p:cNvPicPr>
             <a:picLocks noChangeAspect="1"/>
           </p:cNvPicPr>
@@ -5859,7 +5949,7 @@
       </p:pic>
       <p:sp>
         <p:nvSpPr>
-          <p:cNvPr id="17" name="texto-205"/>
+          <p:cNvPr id="17" name="texto-206"/>
           <p:cNvSpPr txBox="1"/>
           <p:nvPr/>
         </p:nvSpPr>
@@ -5890,7 +5980,7 @@
                   <a:schemeClr val="tx1"/>
                 </a:solidFill>
               </a:rPr>
-              <a:t>Publicar en la Chrome Web Store</a:t>
+              <a:t>Retransmisión con Cloudflare · lista</a:t>
             </a:r>
             <a:endParaRPr lang="en-US" sz="1600" dirty="0"/>
           </a:p>
@@ -5904,7 +5994,7 @@
                   <a:schemeClr val="accent6"/>
                 </a:solidFill>
               </a:rPr>
-              <a:t>Verificar el correo de contacto y enviar a revisión.</a:t>
+              <a:t>Funciona en redes restrictivas; gratis hasta 1.000 GB al mes.</a:t>
             </a:r>
             <a:endParaRPr lang="en-US" sz="1600" dirty="0"/>
           </a:p>
@@ -5912,7 +6002,7 @@
       </p:sp>
       <p:sp>
         <p:nvSpPr>
-          <p:cNvPr id="18" name="icono-fondo-206"/>
+          <p:cNvPr id="18" name="icono-fondo-207"/>
           <p:cNvSpPr/>
           <p:nvPr/>
         </p:nvSpPr>
@@ -5927,14 +6017,14 @@
             </a:avLst>
           </a:prstGeom>
           <a:solidFill>
-            <a:schemeClr val="accent1"/>
+            <a:schemeClr val="accent2"/>
           </a:solidFill>
           <a:ln/>
         </p:spPr>
       </p:sp>
       <p:pic>
         <p:nvPicPr>
-          <p:cNvPr id="19" name="icono-LuCloud-207" descr="preencoded.png">    </p:cNvPr>
+          <p:cNvPr id="19" name="icono-LuCircleCheck-208" descr="preencoded.png">    </p:cNvPr>
           <p:cNvPicPr>
             <a:picLocks noChangeAspect="1"/>
           </p:cNvPicPr>
@@ -5958,7 +6048,7 @@
       </p:pic>
       <p:sp>
         <p:nvSpPr>
-          <p:cNvPr id="20" name="texto-208"/>
+          <p:cNvPr id="20" name="texto-209"/>
           <p:cNvSpPr txBox="1"/>
           <p:nvPr/>
         </p:nvSpPr>
@@ -5989,7 +6079,7 @@
                   <a:schemeClr val="tx1"/>
                 </a:solidFill>
               </a:rPr>
-              <a:t>Retransmisión con Cloudflare</a:t>
+              <a:t>QR nuevo en cada sesión · listo</a:t>
             </a:r>
             <a:endParaRPr lang="en-US" sz="1600" dirty="0"/>
           </a:p>
@@ -6003,7 +6093,7 @@
                   <a:schemeClr val="accent6"/>
                 </a:solidFill>
               </a:rPr>
-              <a:t>Para redes restrictivas; gratis hasta 1.000 GB al mes.</a:t>
+              <a:t>Activado por defecto; se puede desactivar en Ajustes.</a:t>
             </a:r>
             <a:endParaRPr lang="en-US" sz="1600" dirty="0"/>
           </a:p>
@@ -6011,7 +6101,7 @@
       </p:sp>
       <p:sp>
         <p:nvSpPr>
-          <p:cNvPr id="21" name="icono-fondo-209"/>
+          <p:cNvPr id="21" name="icono-fondo-210"/>
           <p:cNvSpPr/>
           <p:nvPr/>
         </p:nvSpPr>
@@ -6033,7 +6123,7 @@
       </p:sp>
       <p:pic>
         <p:nvPicPr>
-          <p:cNvPr id="22" name="icono-LuQrCode-210" descr="preencoded.png">    </p:cNvPr>
+          <p:cNvPr id="22" name="icono-LuHourglass-211" descr="preencoded.png">    </p:cNvPr>
           <p:cNvPicPr>
             <a:picLocks noChangeAspect="1"/>
           </p:cNvPicPr>
@@ -6057,7 +6147,7 @@
       </p:pic>
       <p:sp>
         <p:nvSpPr>
-          <p:cNvPr id="23" name="texto-211"/>
+          <p:cNvPr id="23" name="texto-212"/>
           <p:cNvSpPr txBox="1"/>
           <p:nvPr/>
         </p:nvSpPr>
@@ -6088,7 +6178,7 @@
                   <a:schemeClr val="tx1"/>
                 </a:solidFill>
               </a:rPr>
-              <a:t>QR nuevo en cada sesión</a:t>
+              <a:t>Chrome Web Store</a:t>
             </a:r>
             <a:endParaRPr lang="en-US" sz="1600" dirty="0"/>
           </a:p>
@@ -6102,7 +6192,7 @@
                   <a:schemeClr val="accent6"/>
                 </a:solidFill>
               </a:rPr>
-              <a:t>Una opción en Ajustes para más seguridad.</a:t>
+              <a:t>La versión 1.0 está en revisión; la 1.1 ya está preparada.</a:t>
             </a:r>
             <a:endParaRPr lang="en-US" sz="1600" dirty="0"/>
           </a:p>
@@ -6110,7 +6200,7 @@
       </p:sp>
       <p:sp>
         <p:nvSpPr>
-          <p:cNvPr id="24" name="icono-fondo-212"/>
+          <p:cNvPr id="24" name="icono-fondo-213"/>
           <p:cNvSpPr/>
           <p:nvPr/>
         </p:nvSpPr>
@@ -6132,7 +6222,7 @@
       </p:sp>
       <p:pic>
         <p:nvPicPr>
-          <p:cNvPr id="25" name="icono-LuWatch-213" descr="preencoded.png">    </p:cNvPr>
+          <p:cNvPr id="25" name="icono-LuWatch-214" descr="preencoded.png">    </p:cNvPr>
           <p:cNvPicPr>
             <a:picLocks noChangeAspect="1"/>
           </p:cNvPicPr>
@@ -6156,7 +6246,7 @@
       </p:pic>
       <p:sp>
         <p:nvSpPr>
-          <p:cNvPr id="26" name="texto-214"/>
+          <p:cNvPr id="26" name="texto-215"/>
           <p:cNvSpPr txBox="1"/>
           <p:nvPr/>
         </p:nvSpPr>
@@ -6324,7 +6414,7 @@
           <a:bodyPr wrap="square" lIns="0" tIns="0" rIns="0" bIns="0" rtlCol="0" anchor="b"/>
           <a:lstStyle/>
           <a:p>
-            <a:pPr indent="0" marL="0">
+            <a:pPr algn="l" indent="0" marL="0">
               <a:buNone/>
             </a:pPr>
             <a:r>
@@ -6362,7 +6452,7 @@
           <a:bodyPr wrap="square" lIns="0" tIns="0" rIns="0" bIns="0" rtlCol="0" anchor="t"/>
           <a:lstStyle/>
           <a:p>
-            <a:pPr indent="0" marL="0">
+            <a:pPr algn="l" indent="0" marL="0">
               <a:buNone/>
             </a:pPr>
             <a:r>
@@ -6379,7 +6469,7 @@
       </p:sp>
       <p:pic>
         <p:nvPicPr>
-          <p:cNvPr id="5" name="enlace-icono-215" descr="preencoded.png">    </p:cNvPr>
+          <p:cNvPr id="5" name="enlace-icono-216" descr="preencoded.png">    </p:cNvPr>
           <p:cNvPicPr>
             <a:picLocks noChangeAspect="1"/>
           </p:cNvPicPr>
@@ -6403,7 +6493,7 @@
       </p:pic>
       <p:sp>
         <p:nvSpPr>
-          <p:cNvPr id="6" name="enlace-216"/>
+          <p:cNvPr id="6" name="enlace-217"/>
           <p:cNvSpPr txBox="1"/>
           <p:nvPr/>
         </p:nvSpPr>
@@ -6439,7 +6529,7 @@
       </p:sp>
       <p:pic>
         <p:nvPicPr>
-          <p:cNvPr id="7" name="enlace-icono-217" descr="preencoded.png">    </p:cNvPr>
+          <p:cNvPr id="7" name="enlace-icono-218" descr="preencoded.png">    </p:cNvPr>
           <p:cNvPicPr>
             <a:picLocks noChangeAspect="1"/>
           </p:cNvPicPr>
@@ -6463,7 +6553,7 @@
       </p:pic>
       <p:sp>
         <p:nvSpPr>
-          <p:cNvPr id="8" name="enlace-218"/>
+          <p:cNvPr id="8" name="enlace-219"/>
           <p:cNvSpPr txBox="1"/>
           <p:nvPr/>
         </p:nvSpPr>
@@ -6499,7 +6589,7 @@
       </p:sp>
       <p:pic>
         <p:nvPicPr>
-          <p:cNvPr id="9" name="enlace-icono-219" descr="preencoded.png">    </p:cNvPr>
+          <p:cNvPr id="9" name="enlace-icono-220" descr="preencoded.png">    </p:cNvPr>
           <p:cNvPicPr>
             <a:picLocks noChangeAspect="1"/>
           </p:cNvPicPr>
@@ -6523,7 +6613,7 @@
       </p:pic>
       <p:sp>
         <p:nvSpPr>
-          <p:cNvPr id="10" name="enlace-220"/>
+          <p:cNvPr id="10" name="enlace-221"/>
           <p:cNvSpPr txBox="1"/>
           <p:nvPr/>
         </p:nvSpPr>
@@ -6639,6 +6729,242 @@
           </a:p>
         </p:txBody>
       </p:sp>
+    </p:spTree>
+  </p:cSld>
+  <p:clrMapOvr>
+    <a:masterClrMapping/>
+  </p:clrMapOvr>
+</p:sld>
+</file>
+
+<file path=ppt/slides/slide15.xml><?xml version="1.0" encoding="utf-8"?>
+<p:sld xmlns:a="http://schemas.openxmlformats.org/drawingml/2006/main" xmlns:r="http://schemas.openxmlformats.org/officeDocument/2006/relationships" xmlns:p="http://schemas.openxmlformats.org/presentationml/2006/main">
+  <p:cSld name="Slide 15">
+    <p:spTree>
+      <p:nvGrpSpPr>
+        <p:cNvPr id="1" name=""/>
+        <p:cNvGrpSpPr/>
+        <p:nvPr/>
+      </p:nvGrpSpPr>
+      <p:grpSpPr>
+        <a:xfrm>
+          <a:off x="0" y="0"/>
+          <a:ext cx="0" cy="0"/>
+          <a:chOff x="0" y="0"/>
+          <a:chExt cx="0" cy="0"/>
+        </a:xfrm>
+      </p:grpSpPr>
+      <p:pic>
+        <p:nvPicPr>
+          <p:cNvPr id="2" name="logo-final" descr="Logo de Mando">    </p:cNvPr>
+          <p:cNvPicPr>
+            <a:picLocks noChangeAspect="1"/>
+          </p:cNvPicPr>
+          <p:nvPr/>
+        </p:nvPicPr>
+        <p:blipFill>
+          <a:blip r:embed="rId1"/>
+          <a:stretch>
+            <a:fillRect/>
+          </a:stretch>
+        </p:blipFill>
+        <p:spPr>
+          <a:xfrm>
+            <a:off x="680314" y="1417320"/>
+            <a:ext cx="1143000" cy="1143000"/>
+          </a:xfrm>
+          <a:prstGeom prst="rect">
+            <a:avLst/>
+          </a:prstGeom>
+        </p:spPr>
+      </p:pic>
+      <p:sp>
+        <p:nvSpPr>
+          <p:cNvPr id="3" name="Text 0"/>
+          <p:cNvSpPr/>
+          <p:nvPr>
+            <p:ph idx="100" type="title" hasCustomPrompt="1"/>
+          </p:nvPr>
+        </p:nvSpPr>
+        <p:spPr>
+          <a:xfrm>
+            <a:off x="822960" y="2788920"/>
+            <a:ext cx="4937760" cy="1051560"/>
+          </a:xfrm>
+          <a:prstGeom prst="rect">
+            <a:avLst/>
+          </a:prstGeom>
+          <a:noFill/>
+          <a:ln/>
+        </p:spPr>
+        <p:txBody>
+          <a:bodyPr wrap="square" lIns="0" tIns="0" rIns="0" bIns="0" rtlCol="0" anchor="b"/>
+          <a:lstStyle/>
+          <a:p>
+            <a:pPr algn="l" indent="0" marL="0">
+              <a:buNone/>
+            </a:pPr>
+            <a:r>
+              <a:rPr lang="en-US" sz="6600" b="1" dirty="0">
+                <a:solidFill>
+                  <a:schemeClr val="bg1"/>
+                </a:solidFill>
+              </a:rPr>
+              <a:t>Gracias</a:t>
+            </a:r>
+            <a:endParaRPr lang="en-US" sz="6600" dirty="0"/>
+          </a:p>
+        </p:txBody>
+      </p:sp>
+      <p:sp>
+        <p:nvSpPr>
+          <p:cNvPr id="4" name="Text 0"/>
+          <p:cNvSpPr/>
+          <p:nvPr>
+            <p:ph idx="101" type="body" hasCustomPrompt="1"/>
+          </p:nvPr>
+        </p:nvSpPr>
+        <p:spPr>
+          <a:xfrm>
+            <a:off x="822960" y="3977640"/>
+            <a:ext cx="5120640" cy="914400"/>
+          </a:xfrm>
+          <a:prstGeom prst="rect">
+            <a:avLst/>
+          </a:prstGeom>
+          <a:noFill/>
+          <a:ln/>
+        </p:spPr>
+        <p:txBody>
+          <a:bodyPr wrap="square" lIns="0" tIns="0" rIns="0" bIns="0" rtlCol="0" anchor="t"/>
+          <a:lstStyle/>
+          <a:p>
+            <a:pPr algn="l" indent="0" marL="0">
+              <a:buNone/>
+            </a:pPr>
+            <a:r>
+              <a:rPr lang="en-US" sz="2000" dirty="0">
+                <a:solidFill>
+                  <a:schemeClr val="accent5"/>
+                </a:solidFill>
+              </a:rPr>
+              <a:t>¿Preguntas?</a:t>
+            </a:r>
+            <a:endParaRPr lang="en-US" sz="2000" dirty="0"/>
+          </a:p>
+        </p:txBody>
+      </p:sp>
+      <p:sp>
+        <p:nvSpPr>
+          <p:cNvPr id="5" name="Text 0"/>
+          <p:cNvSpPr/>
+          <p:nvPr>
+            <p:ph idx="102" type="body" hasCustomPrompt="1"/>
+          </p:nvPr>
+        </p:nvSpPr>
+        <p:spPr>
+          <a:xfrm>
+            <a:off x="822960" y="5760720"/>
+            <a:ext cx="4754880" cy="365760"/>
+          </a:xfrm>
+          <a:prstGeom prst="rect">
+            <a:avLst/>
+          </a:prstGeom>
+          <a:noFill/>
+          <a:ln/>
+        </p:spPr>
+        <p:txBody>
+          <a:bodyPr wrap="square" lIns="0" tIns="0" rIns="0" bIns="0" rtlCol="0" anchor="ctr"/>
+          <a:lstStyle/>
+          <a:p>
+            <a:pPr algn="l" indent="0" marL="0">
+              <a:buNone/>
+            </a:pPr>
+            <a:r>
+              <a:rPr lang="en-US" sz="1200" dirty="0">
+                <a:solidFill>
+                  <a:schemeClr val="accent5"/>
+                </a:solidFill>
+              </a:rPr>
+              <a:t>Miguel Mogrovejo · github.com/mjmc4498/mando</a:t>
+            </a:r>
+            <a:endParaRPr lang="en-US" sz="1200" dirty="0"/>
+          </a:p>
+        </p:txBody>
+      </p:sp>
+      <p:sp>
+        <p:nvSpPr>
+          <p:cNvPr id="6" name="marco-222"/>
+          <p:cNvSpPr/>
+          <p:nvPr/>
+        </p:nvSpPr>
+        <p:spPr>
+          <a:xfrm>
+            <a:off x="6126480" y="1691640"/>
+            <a:ext cx="4754880" cy="2674620"/>
+          </a:xfrm>
+          <a:prstGeom prst="rect">
+            <a:avLst/>
+          </a:prstGeom>
+          <a:solidFill>
+            <a:schemeClr val="bg1"/>
+          </a:solidFill>
+          <a:ln w="12700">
+            <a:solidFill>
+              <a:srgbClr val="3A3A3C"/>
+            </a:solidFill>
+            <a:prstDash val="solid"/>
+          </a:ln>
+        </p:spPr>
+      </p:sp>
+      <p:pic>
+        <p:nvPicPr>
+          <p:cNvPr id="7" name="captura-223" descr="Diapositiva con anotaciones del lápiz de Mando">    </p:cNvPr>
+          <p:cNvPicPr>
+            <a:picLocks noChangeAspect="1"/>
+          </p:cNvPicPr>
+          <p:nvPr/>
+        </p:nvPicPr>
+        <p:blipFill>
+          <a:blip r:embed="rId2"/>
+          <a:stretch>
+            <a:fillRect/>
+          </a:stretch>
+        </p:blipFill>
+        <p:spPr>
+          <a:xfrm>
+            <a:off x="6126480" y="1691640"/>
+            <a:ext cx="4754880" cy="2674620"/>
+          </a:xfrm>
+          <a:prstGeom prst="rect">
+            <a:avLst/>
+          </a:prstGeom>
+        </p:spPr>
+      </p:pic>
+      <p:pic>
+        <p:nvPicPr>
+          <p:cNvPr id="8" name="celular-224" descr="Pantalla del lápiz en el control">    </p:cNvPr>
+          <p:cNvPicPr>
+            <a:picLocks noChangeAspect="1"/>
+          </p:cNvPicPr>
+          <p:nvPr/>
+        </p:nvPicPr>
+        <p:blipFill>
+          <a:blip r:embed="rId3"/>
+          <a:stretch>
+            <a:fillRect/>
+          </a:stretch>
+        </p:blipFill>
+        <p:spPr>
+          <a:xfrm>
+            <a:off x="9326880" y="960120"/>
+            <a:ext cx="2349142" cy="4937760"/>
+          </a:xfrm>
+          <a:prstGeom prst="rect">
+            <a:avLst/>
+          </a:prstGeom>
+        </p:spPr>
+      </p:pic>
     </p:spTree>
   </p:cSld>
   <p:clrMapOvr>
@@ -6687,7 +7013,7 @@
           <a:bodyPr wrap="square" lIns="0" tIns="0" rIns="0" bIns="0" rtlCol="0" anchor="ctr"/>
           <a:lstStyle/>
           <a:p>
-            <a:pPr indent="0" marL="0">
+            <a:pPr algn="l" indent="0" marL="0">
               <a:buNone/>
             </a:pPr>
             <a:r>
@@ -6725,7 +7051,7 @@
           <a:bodyPr wrap="square" lIns="0" tIns="0" rIns="0" bIns="0" rtlCol="0" anchor="t"/>
           <a:lstStyle/>
           <a:p>
-            <a:pPr indent="0" marL="0">
+            <a:pPr algn="l" indent="0" marL="0">
               <a:buNone/>
             </a:pPr>
             <a:r>
@@ -6749,7 +7075,7 @@
         <p:spPr>
           <a:xfrm>
             <a:off x="640080" y="1920240"/>
-            <a:ext cx="2522144" cy="3840480"/>
+            <a:ext cx="2522144" cy="3017520"/>
           </a:xfrm>
           <a:prstGeom prst="roundRect">
             <a:avLst>
@@ -6817,7 +7143,7 @@
         <p:spPr>
           <a:xfrm>
             <a:off x="960120" y="3200400"/>
-            <a:ext cx="1882064" cy="2286000"/>
+            <a:ext cx="1882064" cy="1554480"/>
           </a:xfrm>
           <a:prstGeom prst="rect">
             <a:avLst/>
@@ -6870,7 +7196,7 @@
         <p:spPr>
           <a:xfrm>
             <a:off x="3436544" y="1920240"/>
-            <a:ext cx="2522144" cy="3840480"/>
+            <a:ext cx="2522144" cy="3017520"/>
           </a:xfrm>
           <a:prstGeom prst="roundRect">
             <a:avLst>
@@ -6938,7 +7264,7 @@
         <p:spPr>
           <a:xfrm>
             <a:off x="3756584" y="3200400"/>
-            <a:ext cx="1882064" cy="2286000"/>
+            <a:ext cx="1882064" cy="1554480"/>
           </a:xfrm>
           <a:prstGeom prst="rect">
             <a:avLst/>
@@ -6991,7 +7317,7 @@
         <p:spPr>
           <a:xfrm>
             <a:off x="6233008" y="1920240"/>
-            <a:ext cx="2522144" cy="3840480"/>
+            <a:ext cx="2522144" cy="3017520"/>
           </a:xfrm>
           <a:prstGeom prst="roundRect">
             <a:avLst>
@@ -7059,7 +7385,7 @@
         <p:spPr>
           <a:xfrm>
             <a:off x="6553048" y="3200400"/>
-            <a:ext cx="1882064" cy="2286000"/>
+            <a:ext cx="1882064" cy="1554480"/>
           </a:xfrm>
           <a:prstGeom prst="rect">
             <a:avLst/>
@@ -7112,7 +7438,7 @@
         <p:spPr>
           <a:xfrm>
             <a:off x="9029471" y="1920240"/>
-            <a:ext cx="2522144" cy="3840480"/>
+            <a:ext cx="2522144" cy="3017520"/>
           </a:xfrm>
           <a:prstGeom prst="roundRect">
             <a:avLst>
@@ -7180,7 +7506,7 @@
         <p:spPr>
           <a:xfrm>
             <a:off x="9349511" y="3200400"/>
-            <a:ext cx="1882064" cy="2286000"/>
+            <a:ext cx="1882064" cy="1554480"/>
           </a:xfrm>
           <a:prstGeom prst="rect">
             <a:avLst/>
@@ -7221,6 +7547,84 @@
               <a:t>Hacer clic o escribir algo corta el ritmo de la charla.</a:t>
             </a:r>
             <a:endParaRPr lang="en-US" sz="1800" dirty="0"/>
+          </a:p>
+        </p:txBody>
+      </p:sp>
+      <p:sp>
+        <p:nvSpPr>
+          <p:cNvPr id="20" name="tarjeta-20"/>
+          <p:cNvSpPr/>
+          <p:nvPr/>
+        </p:nvSpPr>
+        <p:spPr>
+          <a:xfrm>
+            <a:off x="640080" y="5257800"/>
+            <a:ext cx="10911535" cy="777240"/>
+          </a:xfrm>
+          <a:prstGeom prst="roundRect">
+            <a:avLst>
+              <a:gd name="adj" fmla="val 18824"/>
+            </a:avLst>
+          </a:prstGeom>
+          <a:solidFill>
+            <a:schemeClr val="tx1"/>
+          </a:solidFill>
+          <a:ln/>
+        </p:spPr>
+      </p:sp>
+      <p:sp>
+        <p:nvSpPr>
+          <p:cNvPr id="21" name="punto-laser"/>
+          <p:cNvSpPr/>
+          <p:nvPr/>
+        </p:nvSpPr>
+        <p:spPr>
+          <a:xfrm>
+            <a:off x="1005840" y="5564124"/>
+            <a:ext cx="164592" cy="164592"/>
+          </a:xfrm>
+          <a:prstGeom prst="ellipse">
+            <a:avLst/>
+          </a:prstGeom>
+          <a:solidFill>
+            <a:schemeClr val="accent1"/>
+          </a:solidFill>
+          <a:ln/>
+        </p:spPr>
+      </p:sp>
+      <p:sp>
+        <p:nvSpPr>
+          <p:cNvPr id="22" name="puente"/>
+          <p:cNvSpPr txBox="1"/>
+          <p:nvPr/>
+        </p:nvSpPr>
+        <p:spPr>
+          <a:xfrm>
+            <a:off x="1371600" y="5257800"/>
+            <a:ext cx="9905695" cy="777240"/>
+          </a:xfrm>
+          <a:prstGeom prst="rect">
+            <a:avLst/>
+          </a:prstGeom>
+          <a:noFill/>
+          <a:ln/>
+        </p:spPr>
+        <p:txBody>
+          <a:bodyPr wrap="square" lIns="0" tIns="0" rIns="0" bIns="0" rtlCol="0" anchor="ctr"/>
+          <a:lstStyle/>
+          <a:p>
+            <a:pPr indent="0" marL="0">
+              <a:buNone/>
+            </a:pPr>
+            <a:r>
+              <a:rPr lang="en-US" sz="1700" b="1" dirty="0">
+                <a:solidFill>
+                  <a:schemeClr val="bg1"/>
+                </a:solidFill>
+              </a:rPr>
+              <a:t>Con Mando, todo eso se resuelve desde el celular que ya llevas en el bolsillo.</a:t>
+            </a:r>
+            <a:endParaRPr lang="en-US" sz="1700" dirty="0"/>
           </a:p>
         </p:txBody>
       </p:sp>
@@ -7317,7 +7721,7 @@
           <a:bodyPr wrap="square" lIns="0" tIns="0" rIns="0" bIns="0" rtlCol="0" anchor="ctr"/>
           <a:lstStyle/>
           <a:p>
-            <a:pPr indent="0" marL="0">
+            <a:pPr algn="l" indent="0" marL="0">
               <a:buNone/>
             </a:pPr>
             <a:r>
@@ -7355,7 +7759,7 @@
           <a:bodyPr wrap="square" lIns="0" tIns="0" rIns="0" bIns="0" rtlCol="0" anchor="t"/>
           <a:lstStyle/>
           <a:p>
-            <a:pPr indent="0" marL="0">
+            <a:pPr algn="l" indent="0" marL="0">
               <a:buNone/>
             </a:pPr>
             <a:r>
@@ -7408,7 +7812,7 @@
       </p:sp>
       <p:sp>
         <p:nvSpPr>
-          <p:cNvPr id="5" name="icono-fondo-20"/>
+          <p:cNvPr id="5" name="icono-fondo-21"/>
           <p:cNvSpPr/>
           <p:nvPr/>
         </p:nvSpPr>
@@ -7430,7 +7834,7 @@
       </p:sp>
       <p:pic>
         <p:nvPicPr>
-          <p:cNvPr id="6" name="icono-LuQrCode-21" descr="preencoded.png">    </p:cNvPr>
+          <p:cNvPr id="6" name="icono-LuQrCode-22" descr="preencoded.png">    </p:cNvPr>
           <p:cNvPicPr>
             <a:picLocks noChangeAspect="1"/>
           </p:cNvPicPr>
@@ -7454,7 +7858,7 @@
       </p:pic>
       <p:sp>
         <p:nvSpPr>
-          <p:cNvPr id="7" name="texto-22"/>
+          <p:cNvPr id="7" name="texto-23"/>
           <p:cNvSpPr txBox="1"/>
           <p:nvPr/>
         </p:nvSpPr>
@@ -7507,7 +7911,7 @@
       </p:sp>
       <p:sp>
         <p:nvSpPr>
-          <p:cNvPr id="8" name="icono-fondo-23"/>
+          <p:cNvPr id="8" name="icono-fondo-24"/>
           <p:cNvSpPr/>
           <p:nvPr/>
         </p:nvSpPr>
@@ -7529,7 +7933,7 @@
       </p:sp>
       <p:pic>
         <p:nvPicPr>
-          <p:cNvPr id="9" name="icono-LuLayers-24" descr="preencoded.png">    </p:cNvPr>
+          <p:cNvPr id="9" name="icono-LuLayers-25" descr="preencoded.png">    </p:cNvPr>
           <p:cNvPicPr>
             <a:picLocks noChangeAspect="1"/>
           </p:cNvPicPr>
@@ -7553,7 +7957,7 @@
       </p:pic>
       <p:sp>
         <p:nvSpPr>
-          <p:cNvPr id="10" name="texto-25"/>
+          <p:cNvPr id="10" name="texto-26"/>
           <p:cNvSpPr txBox="1"/>
           <p:nvPr/>
         </p:nvSpPr>
@@ -7606,7 +8010,7 @@
       </p:sp>
       <p:sp>
         <p:nvSpPr>
-          <p:cNvPr id="11" name="icono-fondo-26"/>
+          <p:cNvPr id="11" name="icono-fondo-27"/>
           <p:cNvSpPr/>
           <p:nvPr/>
         </p:nvSpPr>
@@ -7628,7 +8032,7 @@
       </p:sp>
       <p:pic>
         <p:nvPicPr>
-          <p:cNvPr id="12" name="icono-LuShieldCheck-27" descr="preencoded.png">    </p:cNvPr>
+          <p:cNvPr id="12" name="icono-LuShieldCheck-28" descr="preencoded.png">    </p:cNvPr>
           <p:cNvPicPr>
             <a:picLocks noChangeAspect="1"/>
           </p:cNvPicPr>
@@ -7652,7 +8056,7 @@
       </p:pic>
       <p:sp>
         <p:nvSpPr>
-          <p:cNvPr id="13" name="texto-28"/>
+          <p:cNvPr id="13" name="texto-29"/>
           <p:cNvSpPr txBox="1"/>
           <p:nvPr/>
         </p:nvSpPr>
@@ -7705,7 +8109,7 @@
       </p:sp>
       <p:sp>
         <p:nvSpPr>
-          <p:cNvPr id="14" name="marco-29"/>
+          <p:cNvPr id="14" name="marco-30"/>
           <p:cNvSpPr/>
           <p:nvPr/>
         </p:nvSpPr>
@@ -7737,7 +8141,7 @@
       </p:sp>
       <p:pic>
         <p:nvPicPr>
-          <p:cNvPr id="15" name="captura-30" descr="Panel de la extensión con el código QR">    </p:cNvPr>
+          <p:cNvPr id="15" name="captura-31" descr="Panel de la extensión con el código QR">    </p:cNvPr>
           <p:cNvPicPr>
             <a:picLocks noChangeAspect="1"/>
           </p:cNvPicPr>
@@ -7785,7 +8189,7 @@
       </p:pic>
       <p:pic>
         <p:nvPicPr>
-          <p:cNvPr id="17" name="celular-31" descr="Control en el celular">    </p:cNvPr>
+          <p:cNvPr id="17" name="celular-32" descr="Control en el celular">    </p:cNvPr>
           <p:cNvPicPr>
             <a:picLocks noChangeAspect="1"/>
           </p:cNvPicPr>
@@ -7900,7 +8304,7 @@
           <a:bodyPr wrap="square" lIns="0" tIns="0" rIns="0" bIns="0" rtlCol="0" anchor="ctr"/>
           <a:lstStyle/>
           <a:p>
-            <a:pPr indent="0" marL="0">
+            <a:pPr algn="l" indent="0" marL="0">
               <a:buNone/>
             </a:pPr>
             <a:r>
@@ -7938,7 +8342,7 @@
           <a:bodyPr wrap="square" lIns="0" tIns="0" rIns="0" bIns="0" rtlCol="0" anchor="t"/>
           <a:lstStyle/>
           <a:p>
-            <a:pPr indent="0" marL="0">
+            <a:pPr algn="l" indent="0" marL="0">
               <a:buNone/>
             </a:pPr>
             <a:r>
@@ -7955,7 +8359,7 @@
       </p:sp>
       <p:sp>
         <p:nvSpPr>
-          <p:cNvPr id="4" name="tarjeta-32"/>
+          <p:cNvPr id="4" name="tarjeta-33"/>
           <p:cNvSpPr/>
           <p:nvPr/>
         </p:nvSpPr>
@@ -7977,7 +8381,7 @@
       </p:sp>
       <p:sp>
         <p:nvSpPr>
-          <p:cNvPr id="5" name="marco-33"/>
+          <p:cNvPr id="5" name="marco-34"/>
           <p:cNvSpPr/>
           <p:nvPr/>
         </p:nvSpPr>
@@ -8009,7 +8413,7 @@
       </p:sp>
       <p:pic>
         <p:nvPicPr>
-          <p:cNvPr id="6" name="captura-34" descr="Presentación abierta en Chrome">    </p:cNvPr>
+          <p:cNvPr id="6" name="captura-35" descr="Presentación abierta en Chrome">    </p:cNvPr>
           <p:cNvPicPr>
             <a:picLocks noChangeAspect="1"/>
           </p:cNvPicPr>
@@ -8033,7 +8437,7 @@
       </p:pic>
       <p:sp>
         <p:nvSpPr>
-          <p:cNvPr id="7" name="numero-35"/>
+          <p:cNvPr id="7" name="numero-36"/>
           <p:cNvSpPr/>
           <p:nvPr/>
         </p:nvSpPr>
@@ -8053,7 +8457,7 @@
       </p:sp>
       <p:sp>
         <p:nvSpPr>
-          <p:cNvPr id="8" name="numero-texto-36"/>
+          <p:cNvPr id="8" name="numero-texto-37"/>
           <p:cNvSpPr txBox="1"/>
           <p:nvPr/>
         </p:nvSpPr>
@@ -8089,7 +8493,7 @@
       </p:sp>
       <p:sp>
         <p:nvSpPr>
-          <p:cNvPr id="9" name="texto-37"/>
+          <p:cNvPr id="9" name="texto-38"/>
           <p:cNvSpPr txBox="1"/>
           <p:nvPr/>
         </p:nvSpPr>
@@ -8142,7 +8546,7 @@
       </p:sp>
       <p:pic>
         <p:nvPicPr>
-          <p:cNvPr id="10" name="flecha-38" descr="preencoded.png">    </p:cNvPr>
+          <p:cNvPr id="10" name="flecha-39" descr="preencoded.png">    </p:cNvPr>
           <p:cNvPicPr>
             <a:picLocks noChangeAspect="1"/>
           </p:cNvPicPr>
@@ -8166,7 +8570,7 @@
       </p:pic>
       <p:sp>
         <p:nvSpPr>
-          <p:cNvPr id="11" name="tarjeta-39"/>
+          <p:cNvPr id="11" name="tarjeta-40"/>
           <p:cNvSpPr/>
           <p:nvPr/>
         </p:nvSpPr>
@@ -8188,7 +8592,7 @@
       </p:sp>
       <p:sp>
         <p:nvSpPr>
-          <p:cNvPr id="12" name="marco-40"/>
+          <p:cNvPr id="12" name="marco-41"/>
           <p:cNvSpPr/>
           <p:nvPr/>
         </p:nvSpPr>
@@ -8220,7 +8624,7 @@
       </p:sp>
       <p:pic>
         <p:nvPicPr>
-          <p:cNvPr id="13" name="captura-41" descr="Código QR de Mando">    </p:cNvPr>
+          <p:cNvPr id="13" name="captura-42" descr="Código QR de Mando">    </p:cNvPr>
           <p:cNvPicPr>
             <a:picLocks noChangeAspect="1"/>
           </p:cNvPicPr>
@@ -8244,7 +8648,7 @@
       </p:pic>
       <p:sp>
         <p:nvSpPr>
-          <p:cNvPr id="14" name="numero-42"/>
+          <p:cNvPr id="14" name="numero-43"/>
           <p:cNvSpPr/>
           <p:nvPr/>
         </p:nvSpPr>
@@ -8264,7 +8668,7 @@
       </p:sp>
       <p:sp>
         <p:nvSpPr>
-          <p:cNvPr id="15" name="numero-texto-43"/>
+          <p:cNvPr id="15" name="numero-texto-44"/>
           <p:cNvSpPr txBox="1"/>
           <p:nvPr/>
         </p:nvSpPr>
@@ -8300,7 +8704,7 @@
       </p:sp>
       <p:sp>
         <p:nvSpPr>
-          <p:cNvPr id="16" name="texto-44"/>
+          <p:cNvPr id="16" name="texto-45"/>
           <p:cNvSpPr txBox="1"/>
           <p:nvPr/>
         </p:nvSpPr>
@@ -8353,7 +8757,7 @@
       </p:sp>
       <p:pic>
         <p:nvPicPr>
-          <p:cNvPr id="17" name="flecha-45" descr="preencoded.png">    </p:cNvPr>
+          <p:cNvPr id="17" name="flecha-46" descr="preencoded.png">    </p:cNvPr>
           <p:cNvPicPr>
             <a:picLocks noChangeAspect="1"/>
           </p:cNvPicPr>
@@ -8377,7 +8781,7 @@
       </p:pic>
       <p:sp>
         <p:nvSpPr>
-          <p:cNvPr id="18" name="tarjeta-46"/>
+          <p:cNvPr id="18" name="tarjeta-47"/>
           <p:cNvSpPr/>
           <p:nvPr/>
         </p:nvSpPr>
@@ -8399,7 +8803,7 @@
       </p:sp>
       <p:pic>
         <p:nvPicPr>
-          <p:cNvPr id="19" name="celular-47" descr="Control en el celular">    </p:cNvPr>
+          <p:cNvPr id="19" name="celular-48" descr="Control en el celular">    </p:cNvPr>
           <p:cNvPicPr>
             <a:picLocks noChangeAspect="1"/>
           </p:cNvPicPr>
@@ -8423,7 +8827,7 @@
       </p:pic>
       <p:sp>
         <p:nvSpPr>
-          <p:cNvPr id="20" name="numero-48"/>
+          <p:cNvPr id="20" name="numero-49"/>
           <p:cNvSpPr/>
           <p:nvPr/>
         </p:nvSpPr>
@@ -8443,7 +8847,7 @@
       </p:sp>
       <p:sp>
         <p:nvSpPr>
-          <p:cNvPr id="21" name="numero-texto-49"/>
+          <p:cNvPr id="21" name="numero-texto-50"/>
           <p:cNvSpPr txBox="1"/>
           <p:nvPr/>
         </p:nvSpPr>
@@ -8479,7 +8883,7 @@
       </p:sp>
       <p:sp>
         <p:nvSpPr>
-          <p:cNvPr id="22" name="texto-50"/>
+          <p:cNvPr id="22" name="texto-51"/>
           <p:cNvSpPr txBox="1"/>
           <p:nvPr/>
         </p:nvSpPr>
@@ -8623,7 +9027,7 @@
           <a:bodyPr wrap="square" lIns="0" tIns="0" rIns="0" bIns="0" rtlCol="0" anchor="ctr"/>
           <a:lstStyle/>
           <a:p>
-            <a:pPr indent="0" marL="0">
+            <a:pPr algn="l" indent="0" marL="0">
               <a:buNone/>
             </a:pPr>
             <a:r>
@@ -8661,7 +9065,7 @@
           <a:bodyPr wrap="square" lIns="0" tIns="0" rIns="0" bIns="0" rtlCol="0" anchor="t"/>
           <a:lstStyle/>
           <a:p>
-            <a:pPr indent="0" marL="0">
+            <a:pPr algn="l" indent="0" marL="0">
               <a:buNone/>
             </a:pPr>
             <a:r>
@@ -8678,7 +9082,7 @@
       </p:sp>
       <p:pic>
         <p:nvPicPr>
-          <p:cNvPr id="4" name="celular-51" descr="Pantalla de diapositivas del control">    </p:cNvPr>
+          <p:cNvPr id="4" name="celular-52" descr="Pantalla de diapositivas del control">    </p:cNvPr>
           <p:cNvPicPr>
             <a:picLocks noChangeAspect="1"/>
           </p:cNvPicPr>
@@ -8702,7 +9106,7 @@
       </p:pic>
       <p:sp>
         <p:nvSpPr>
-          <p:cNvPr id="5" name="icono-fondo-52"/>
+          <p:cNvPr id="5" name="icono-fondo-53"/>
           <p:cNvSpPr/>
           <p:nvPr/>
         </p:nvSpPr>
@@ -8724,7 +9128,7 @@
       </p:sp>
       <p:pic>
         <p:nvPicPr>
-          <p:cNvPr id="6" name="icono-LuChevronRight-53" descr="preencoded.png">    </p:cNvPr>
+          <p:cNvPr id="6" name="icono-LuChevronRight-54" descr="preencoded.png">    </p:cNvPr>
           <p:cNvPicPr>
             <a:picLocks noChangeAspect="1"/>
           </p:cNvPicPr>
@@ -8748,7 +9152,7 @@
       </p:pic>
       <p:sp>
         <p:nvSpPr>
-          <p:cNvPr id="7" name="texto-54"/>
+          <p:cNvPr id="7" name="texto-55"/>
           <p:cNvSpPr txBox="1"/>
           <p:nvPr/>
         </p:nvSpPr>
@@ -8801,7 +9205,7 @@
       </p:sp>
       <p:sp>
         <p:nvSpPr>
-          <p:cNvPr id="8" name="icono-fondo-55"/>
+          <p:cNvPr id="8" name="icono-fondo-56"/>
           <p:cNvSpPr/>
           <p:nvPr/>
         </p:nvSpPr>
@@ -8823,7 +9227,7 @@
       </p:sp>
       <p:pic>
         <p:nvPicPr>
-          <p:cNvPr id="9" name="icono-LuPlay-56" descr="preencoded.png">    </p:cNvPr>
+          <p:cNvPr id="9" name="icono-LuPlay-57" descr="preencoded.png">    </p:cNvPr>
           <p:cNvPicPr>
             <a:picLocks noChangeAspect="1"/>
           </p:cNvPicPr>
@@ -8847,7 +9251,7 @@
       </p:pic>
       <p:sp>
         <p:nvSpPr>
-          <p:cNvPr id="10" name="texto-57"/>
+          <p:cNvPr id="10" name="texto-58"/>
           <p:cNvSpPr txBox="1"/>
           <p:nvPr/>
         </p:nvSpPr>
@@ -8900,7 +9304,7 @@
       </p:sp>
       <p:sp>
         <p:nvSpPr>
-          <p:cNvPr id="11" name="icono-fondo-58"/>
+          <p:cNvPr id="11" name="icono-fondo-59"/>
           <p:cNvSpPr/>
           <p:nvPr/>
         </p:nvSpPr>
@@ -8922,7 +9326,7 @@
       </p:sp>
       <p:pic>
         <p:nvPicPr>
-          <p:cNvPr id="12" name="icono-LuSquare-59" descr="preencoded.png">    </p:cNvPr>
+          <p:cNvPr id="12" name="icono-LuSquare-60" descr="preencoded.png">    </p:cNvPr>
           <p:cNvPicPr>
             <a:picLocks noChangeAspect="1"/>
           </p:cNvPicPr>
@@ -8946,7 +9350,7 @@
       </p:pic>
       <p:sp>
         <p:nvSpPr>
-          <p:cNvPr id="13" name="texto-60"/>
+          <p:cNvPr id="13" name="texto-61"/>
           <p:cNvSpPr txBox="1"/>
           <p:nvPr/>
         </p:nvSpPr>
@@ -8999,7 +9403,7 @@
       </p:sp>
       <p:sp>
         <p:nvSpPr>
-          <p:cNvPr id="14" name="icono-fondo-61"/>
+          <p:cNvPr id="14" name="icono-fondo-62"/>
           <p:cNvSpPr/>
           <p:nvPr/>
         </p:nvSpPr>
@@ -9021,7 +9425,7 @@
       </p:sp>
       <p:pic>
         <p:nvPicPr>
-          <p:cNvPr id="15" name="icono-LuTimer-62" descr="preencoded.png">    </p:cNvPr>
+          <p:cNvPr id="15" name="icono-LuTimer-63" descr="preencoded.png">    </p:cNvPr>
           <p:cNvPicPr>
             <a:picLocks noChangeAspect="1"/>
           </p:cNvPicPr>
@@ -9045,7 +9449,7 @@
       </p:pic>
       <p:sp>
         <p:nvSpPr>
-          <p:cNvPr id="16" name="texto-63"/>
+          <p:cNvPr id="16" name="texto-64"/>
           <p:cNvSpPr txBox="1"/>
           <p:nvPr/>
         </p:nvSpPr>
@@ -9098,7 +9502,7 @@
       </p:sp>
       <p:sp>
         <p:nvSpPr>
-          <p:cNvPr id="17" name="icono-fondo-64"/>
+          <p:cNvPr id="17" name="icono-fondo-65"/>
           <p:cNvSpPr/>
           <p:nvPr/>
         </p:nvSpPr>
@@ -9120,7 +9524,7 @@
       </p:sp>
       <p:pic>
         <p:nvPicPr>
-          <p:cNvPr id="18" name="icono-LuVibrate-65" descr="preencoded.png">    </p:cNvPr>
+          <p:cNvPr id="18" name="icono-LuVibrate-66" descr="preencoded.png">    </p:cNvPr>
           <p:cNvPicPr>
             <a:picLocks noChangeAspect="1"/>
           </p:cNvPicPr>
@@ -9144,7 +9548,7 @@
       </p:pic>
       <p:sp>
         <p:nvSpPr>
-          <p:cNvPr id="19" name="texto-66"/>
+          <p:cNvPr id="19" name="texto-67"/>
           <p:cNvSpPr txBox="1"/>
           <p:nvPr/>
         </p:nvSpPr>
@@ -9288,7 +9692,7 @@
           <a:bodyPr wrap="square" lIns="0" tIns="0" rIns="0" bIns="0" rtlCol="0" anchor="ctr"/>
           <a:lstStyle/>
           <a:p>
-            <a:pPr indent="0" marL="0">
+            <a:pPr algn="l" indent="0" marL="0">
               <a:buNone/>
             </a:pPr>
             <a:r>
@@ -9326,7 +9730,7 @@
           <a:bodyPr wrap="square" lIns="0" tIns="0" rIns="0" bIns="0" rtlCol="0" anchor="t"/>
           <a:lstStyle/>
           <a:p>
-            <a:pPr indent="0" marL="0">
+            <a:pPr algn="l" indent="0" marL="0">
               <a:buNone/>
             </a:pPr>
             <a:r>
@@ -9343,7 +9747,7 @@
       </p:sp>
       <p:sp>
         <p:nvSpPr>
-          <p:cNvPr id="4" name="marco-67"/>
+          <p:cNvPr id="4" name="marco-68"/>
           <p:cNvSpPr/>
           <p:nvPr/>
         </p:nvSpPr>
@@ -9368,7 +9772,7 @@
       </p:sp>
       <p:pic>
         <p:nvPicPr>
-          <p:cNvPr id="5" name="captura-68" descr="Láser con estela">    </p:cNvPr>
+          <p:cNvPr id="5" name="captura-69" descr="Láser con estela">    </p:cNvPr>
           <p:cNvPicPr>
             <a:picLocks noChangeAspect="1"/>
           </p:cNvPicPr>
@@ -9392,7 +9796,7 @@
       </p:pic>
       <p:sp>
         <p:nvSpPr>
-          <p:cNvPr id="6" name="texto-69"/>
+          <p:cNvPr id="6" name="texto-70"/>
           <p:cNvSpPr txBox="1"/>
           <p:nvPr/>
         </p:nvSpPr>
@@ -9445,7 +9849,7 @@
       </p:sp>
       <p:sp>
         <p:nvSpPr>
-          <p:cNvPr id="7" name="marco-70"/>
+          <p:cNvPr id="7" name="marco-71"/>
           <p:cNvSpPr/>
           <p:nvPr/>
         </p:nvSpPr>
@@ -9470,7 +9874,7 @@
       </p:sp>
       <p:pic>
         <p:nvPicPr>
-          <p:cNvPr id="8" name="captura-71" descr="Foco de luz">    </p:cNvPr>
+          <p:cNvPr id="8" name="captura-72" descr="Foco de luz">    </p:cNvPr>
           <p:cNvPicPr>
             <a:picLocks noChangeAspect="1"/>
           </p:cNvPicPr>
@@ -9494,7 +9898,7 @@
       </p:pic>
       <p:sp>
         <p:nvSpPr>
-          <p:cNvPr id="9" name="texto-72"/>
+          <p:cNvPr id="9" name="texto-73"/>
           <p:cNvSpPr txBox="1"/>
           <p:nvPr/>
         </p:nvSpPr>
@@ -9547,7 +9951,7 @@
       </p:sp>
       <p:sp>
         <p:nvSpPr>
-          <p:cNvPr id="10" name="marco-73"/>
+          <p:cNvPr id="10" name="marco-74"/>
           <p:cNvSpPr/>
           <p:nvPr/>
         </p:nvSpPr>
@@ -9572,7 +9976,7 @@
       </p:sp>
       <p:pic>
         <p:nvPicPr>
-          <p:cNvPr id="11" name="captura-74" descr="Lápiz de colores">    </p:cNvPr>
+          <p:cNvPr id="11" name="captura-75" descr="Lápiz de colores">    </p:cNvPr>
           <p:cNvPicPr>
             <a:picLocks noChangeAspect="1"/>
           </p:cNvPicPr>
@@ -9596,7 +10000,7 @@
       </p:pic>
       <p:sp>
         <p:nvSpPr>
-          <p:cNvPr id="12" name="texto-75"/>
+          <p:cNvPr id="12" name="texto-76"/>
           <p:cNvSpPr txBox="1"/>
           <p:nvPr/>
         </p:nvSpPr>
@@ -9649,7 +10053,7 @@
       </p:sp>
       <p:sp>
         <p:nvSpPr>
-          <p:cNvPr id="13" name="icono-fondo-76"/>
+          <p:cNvPr id="13" name="icono-fondo-77"/>
           <p:cNvSpPr/>
           <p:nvPr/>
         </p:nvSpPr>
@@ -9671,7 +10075,7 @@
       </p:sp>
       <p:pic>
         <p:nvPicPr>
-          <p:cNvPr id="14" name="icono-LuSmartphone-77" descr="preencoded.png">    </p:cNvPr>
+          <p:cNvPr id="14" name="icono-LuSmartphone-78" descr="preencoded.png">    </p:cNvPr>
           <p:cNvPicPr>
             <a:picLocks noChangeAspect="1"/>
           </p:cNvPicPr>
@@ -9833,7 +10237,7 @@
           <a:bodyPr wrap="square" lIns="0" tIns="0" rIns="0" bIns="0" rtlCol="0" anchor="ctr"/>
           <a:lstStyle/>
           <a:p>
-            <a:pPr indent="0" marL="0">
+            <a:pPr algn="l" indent="0" marL="0">
               <a:buNone/>
             </a:pPr>
             <a:r>
@@ -9871,7 +10275,7 @@
           <a:bodyPr wrap="square" lIns="0" tIns="0" rIns="0" bIns="0" rtlCol="0" anchor="t"/>
           <a:lstStyle/>
           <a:p>
-            <a:pPr indent="0" marL="0">
+            <a:pPr algn="l" indent="0" marL="0">
               <a:buNone/>
             </a:pPr>
             <a:r>
@@ -9888,7 +10292,7 @@
       </p:sp>
       <p:pic>
         <p:nvPicPr>
-          <p:cNvPr id="4" name="celular-78" descr="Panel táctil del control">    </p:cNvPr>
+          <p:cNvPr id="4" name="celular-79" descr="Panel táctil del control">    </p:cNvPr>
           <p:cNvPicPr>
             <a:picLocks noChangeAspect="1"/>
           </p:cNvPicPr>
@@ -9912,7 +10316,7 @@
       </p:pic>
       <p:pic>
         <p:nvPicPr>
-          <p:cNvPr id="5" name="celular-79" descr="Teclado del control">    </p:cNvPr>
+          <p:cNvPr id="5" name="celular-80" descr="Teclado del control">    </p:cNvPr>
           <p:cNvPicPr>
             <a:picLocks noChangeAspect="1"/>
           </p:cNvPicPr>
@@ -9936,7 +10340,7 @@
       </p:pic>
       <p:sp>
         <p:nvSpPr>
-          <p:cNvPr id="6" name="marco-80"/>
+          <p:cNvPr id="6" name="marco-81"/>
           <p:cNvSpPr/>
           <p:nvPr/>
         </p:nvSpPr>
@@ -9968,7 +10372,7 @@
       </p:sp>
       <p:pic>
         <p:nvPicPr>
-          <p:cNvPr id="7" name="captura-81" descr="Cursor remoto sobre la presentación">    </p:cNvPr>
+          <p:cNvPr id="7" name="captura-82" descr="Cursor remoto sobre la presentación">    </p:cNvPr>
           <p:cNvPicPr>
             <a:picLocks noChangeAspect="1"/>
           </p:cNvPicPr>
@@ -9992,7 +10396,7 @@
       </p:pic>
       <p:sp>
         <p:nvSpPr>
-          <p:cNvPr id="8" name="texto-82"/>
+          <p:cNvPr id="8" name="texto-83"/>
           <p:cNvSpPr txBox="1"/>
           <p:nvPr/>
         </p:nvSpPr>
@@ -10045,7 +10449,7 @@
       </p:sp>
       <p:sp>
         <p:nvSpPr>
-          <p:cNvPr id="9" name="texto-83"/>
+          <p:cNvPr id="9" name="texto-84"/>
           <p:cNvSpPr txBox="1"/>
           <p:nvPr/>
         </p:nvSpPr>
@@ -10189,7 +10593,7 @@
           <a:bodyPr wrap="square" lIns="0" tIns="0" rIns="0" bIns="0" rtlCol="0" anchor="ctr"/>
           <a:lstStyle/>
           <a:p>
-            <a:pPr indent="0" marL="0">
+            <a:pPr algn="l" indent="0" marL="0">
               <a:buNone/>
             </a:pPr>
             <a:r>
@@ -10227,7 +10631,7 @@
           <a:bodyPr wrap="square" lIns="0" tIns="0" rIns="0" bIns="0" rtlCol="0" anchor="t"/>
           <a:lstStyle/>
           <a:p>
-            <a:pPr indent="0" marL="0">
+            <a:pPr algn="l" indent="0" marL="0">
               <a:buNone/>
             </a:pPr>
             <a:r>
@@ -10244,7 +10648,7 @@
       </p:sp>
       <p:sp>
         <p:nvSpPr>
-          <p:cNvPr id="4" name="tarjeta-84"/>
+          <p:cNvPr id="4" name="tarjeta-85"/>
           <p:cNvSpPr/>
           <p:nvPr/>
         </p:nvSpPr>
@@ -10266,7 +10670,7 @@
       </p:sp>
       <p:sp>
         <p:nvSpPr>
-          <p:cNvPr id="5" name="icono-fondo-85"/>
+          <p:cNvPr id="5" name="icono-fondo-86"/>
           <p:cNvSpPr/>
           <p:nvPr/>
         </p:nvSpPr>
@@ -10288,7 +10692,7 @@
       </p:sp>
       <p:pic>
         <p:nvPicPr>
-          <p:cNvPr id="6" name="icono-LuQrCode-86" descr="preencoded.png">    </p:cNvPr>
+          <p:cNvPr id="6" name="icono-LuQrCode-87" descr="preencoded.png">    </p:cNvPr>
           <p:cNvPicPr>
             <a:picLocks noChangeAspect="1"/>
           </p:cNvPicPr>
@@ -10312,7 +10716,7 @@
       </p:pic>
       <p:sp>
         <p:nvSpPr>
-          <p:cNvPr id="7" name="texto-87"/>
+          <p:cNvPr id="7" name="texto-88"/>
           <p:cNvSpPr txBox="1"/>
           <p:nvPr/>
         </p:nvSpPr>
@@ -10365,7 +10769,7 @@
       </p:sp>
       <p:sp>
         <p:nvSpPr>
-          <p:cNvPr id="8" name="tarjeta-88"/>
+          <p:cNvPr id="8" name="tarjeta-89"/>
           <p:cNvSpPr/>
           <p:nvPr/>
         </p:nvSpPr>
@@ -10387,7 +10791,7 @@
       </p:sp>
       <p:sp>
         <p:nvSpPr>
-          <p:cNvPr id="9" name="icono-fondo-89"/>
+          <p:cNvPr id="9" name="icono-fondo-90"/>
           <p:cNvSpPr/>
           <p:nvPr/>
         </p:nvSpPr>
@@ -10409,7 +10813,7 @@
       </p:sp>
       <p:pic>
         <p:nvPicPr>
-          <p:cNvPr id="10" name="icono-LuWallet-90" descr="preencoded.png">    </p:cNvPr>
+          <p:cNvPr id="10" name="icono-LuWallet-91" descr="preencoded.png">    </p:cNvPr>
           <p:cNvPicPr>
             <a:picLocks noChangeAspect="1"/>
           </p:cNvPicPr>
@@ -10433,7 +10837,7 @@
       </p:pic>
       <p:sp>
         <p:nvSpPr>
-          <p:cNvPr id="11" name="texto-91"/>
+          <p:cNvPr id="11" name="texto-92"/>
           <p:cNvSpPr txBox="1"/>
           <p:nvPr/>
         </p:nvSpPr>
@@ -10486,7 +10890,7 @@
       </p:sp>
       <p:sp>
         <p:nvSpPr>
-          <p:cNvPr id="12" name="tarjeta-92"/>
+          <p:cNvPr id="12" name="tarjeta-93"/>
           <p:cNvSpPr/>
           <p:nvPr/>
         </p:nvSpPr>
@@ -10508,7 +10912,7 @@
       </p:sp>
       <p:sp>
         <p:nvSpPr>
-          <p:cNvPr id="13" name="icono-fondo-93"/>
+          <p:cNvPr id="13" name="icono-fondo-94"/>
           <p:cNvSpPr/>
           <p:nvPr/>
         </p:nvSpPr>
@@ -10530,7 +10934,7 @@
       </p:sp>
       <p:pic>
         <p:nvPicPr>
-          <p:cNvPr id="14" name="icono-LuMove-94" descr="preencoded.png">    </p:cNvPr>
+          <p:cNvPr id="14" name="icono-LuMove-95" descr="preencoded.png">    </p:cNvPr>
           <p:cNvPicPr>
             <a:picLocks noChangeAspect="1"/>
           </p:cNvPicPr>
@@ -10554,7 +10958,7 @@
       </p:pic>
       <p:sp>
         <p:nvSpPr>
-          <p:cNvPr id="15" name="texto-95"/>
+          <p:cNvPr id="15" name="texto-96"/>
           <p:cNvSpPr txBox="1"/>
           <p:nvPr/>
         </p:nvSpPr>
@@ -10607,7 +11011,7 @@
       </p:sp>
       <p:sp>
         <p:nvSpPr>
-          <p:cNvPr id="16" name="tarjeta-96"/>
+          <p:cNvPr id="16" name="tarjeta-97"/>
           <p:cNvSpPr/>
           <p:nvPr/>
         </p:nvSpPr>
@@ -10629,7 +11033,7 @@
       </p:sp>
       <p:sp>
         <p:nvSpPr>
-          <p:cNvPr id="17" name="icono-fondo-97"/>
+          <p:cNvPr id="17" name="icono-fondo-98"/>
           <p:cNvSpPr/>
           <p:nvPr/>
         </p:nvSpPr>
@@ -10651,7 +11055,7 @@
       </p:sp>
       <p:pic>
         <p:nvPicPr>
-          <p:cNvPr id="18" name="icono-LuMonitorSmartphone-98" descr="preencoded.png">    </p:cNvPr>
+          <p:cNvPr id="18" name="icono-LuMonitorSmartphone-99" descr="preencoded.png">    </p:cNvPr>
           <p:cNvPicPr>
             <a:picLocks noChangeAspect="1"/>
           </p:cNvPicPr>
@@ -10675,7 +11079,7 @@
       </p:pic>
       <p:sp>
         <p:nvSpPr>
-          <p:cNvPr id="19" name="texto-99"/>
+          <p:cNvPr id="19" name="texto-100"/>
           <p:cNvSpPr txBox="1"/>
           <p:nvPr/>
         </p:nvSpPr>
@@ -10728,7 +11132,7 @@
       </p:sp>
       <p:sp>
         <p:nvSpPr>
-          <p:cNvPr id="20" name="tarjeta-100"/>
+          <p:cNvPr id="20" name="tarjeta-101"/>
           <p:cNvSpPr/>
           <p:nvPr/>
         </p:nvSpPr>
@@ -10750,7 +11154,7 @@
       </p:sp>
       <p:sp>
         <p:nvSpPr>
-          <p:cNvPr id="21" name="icono-fondo-101"/>
+          <p:cNvPr id="21" name="icono-fondo-102"/>
           <p:cNvSpPr/>
           <p:nvPr/>
         </p:nvSpPr>
@@ -10772,7 +11176,7 @@
       </p:sp>
       <p:pic>
         <p:nvPicPr>
-          <p:cNvPr id="22" name="icono-LuLayers-102" descr="preencoded.png">    </p:cNvPr>
+          <p:cNvPr id="22" name="icono-LuLayers-103" descr="preencoded.png">    </p:cNvPr>
           <p:cNvPicPr>
             <a:picLocks noChangeAspect="1"/>
           </p:cNvPicPr>
@@ -10796,7 +11200,7 @@
       </p:pic>
       <p:sp>
         <p:nvSpPr>
-          <p:cNvPr id="23" name="texto-103"/>
+          <p:cNvPr id="23" name="texto-104"/>
           <p:cNvSpPr txBox="1"/>
           <p:nvPr/>
         </p:nvSpPr>
@@ -10849,7 +11253,7 @@
       </p:sp>
       <p:sp>
         <p:nvSpPr>
-          <p:cNvPr id="24" name="tarjeta-104"/>
+          <p:cNvPr id="24" name="tarjeta-105"/>
           <p:cNvSpPr/>
           <p:nvPr/>
         </p:nvSpPr>
@@ -10871,7 +11275,7 @@
       </p:sp>
       <p:sp>
         <p:nvSpPr>
-          <p:cNvPr id="25" name="icono-fondo-105"/>
+          <p:cNvPr id="25" name="icono-fondo-106"/>
           <p:cNvSpPr/>
           <p:nvPr/>
         </p:nvSpPr>
@@ -10893,7 +11297,7 @@
       </p:sp>
       <p:pic>
         <p:nvPicPr>
-          <p:cNvPr id="26" name="icono-LuShieldCheck-106" descr="preencoded.png">    </p:cNvPr>
+          <p:cNvPr id="26" name="icono-LuShieldCheck-107" descr="preencoded.png">    </p:cNvPr>
           <p:cNvPicPr>
             <a:picLocks noChangeAspect="1"/>
           </p:cNvPicPr>
@@ -10917,7 +11321,7 @@
       </p:pic>
       <p:sp>
         <p:nvSpPr>
-          <p:cNvPr id="27" name="texto-107"/>
+          <p:cNvPr id="27" name="texto-108"/>
           <p:cNvSpPr txBox="1"/>
           <p:nvPr/>
         </p:nvSpPr>
@@ -11061,7 +11465,7 @@
           <a:bodyPr wrap="square" lIns="0" tIns="0" rIns="0" bIns="0" rtlCol="0" anchor="ctr"/>
           <a:lstStyle/>
           <a:p>
-            <a:pPr indent="0" marL="0">
+            <a:pPr algn="l" indent="0" marL="0">
               <a:buNone/>
             </a:pPr>
             <a:r>
@@ -11099,7 +11503,7 @@
           <a:bodyPr wrap="square" lIns="0" tIns="0" rIns="0" bIns="0" rtlCol="0" anchor="t"/>
           <a:lstStyle/>
           <a:p>
-            <a:pPr indent="0" marL="0">
+            <a:pPr algn="l" indent="0" marL="0">
               <a:buNone/>
             </a:pPr>
             <a:r>
@@ -11116,7 +11520,7 @@
       </p:sp>
       <p:sp>
         <p:nvSpPr>
-          <p:cNvPr id="4" name="icono-fondo-108"/>
+          <p:cNvPr id="4" name="icono-fondo-109"/>
           <p:cNvSpPr/>
           <p:nvPr/>
         </p:nvSpPr>
@@ -11138,7 +11542,7 @@
       </p:sp>
       <p:pic>
         <p:nvPicPr>
-          <p:cNvPr id="5" name="icono-LuPresentation-109" descr="preencoded.png">    </p:cNvPr>
+          <p:cNvPr id="5" name="icono-LuPresentation-110" descr="preencoded.png">    </p:cNvPr>
           <p:cNvPicPr>
             <a:picLocks noChangeAspect="1"/>
           </p:cNvPicPr>
@@ -11198,7 +11602,7 @@
       </p:sp>
       <p:sp>
         <p:nvSpPr>
-          <p:cNvPr id="7" name="chip-110"/>
+          <p:cNvPr id="7" name="chip-111"/>
           <p:cNvSpPr/>
           <p:nvPr/>
         </p:nvSpPr>
@@ -11220,7 +11624,7 @@
       </p:sp>
       <p:pic>
         <p:nvPicPr>
-          <p:cNvPr id="8" name="verificado-111" descr="Verificado">    </p:cNvPr>
+          <p:cNvPr id="8" name="verificado-112" descr="Verificado">    </p:cNvPr>
           <p:cNvPicPr>
             <a:picLocks noChangeAspect="1"/>
           </p:cNvPicPr>
@@ -11244,7 +11648,7 @@
       </p:pic>
       <p:sp>
         <p:nvSpPr>
-          <p:cNvPr id="9" name="chip-texto-112"/>
+          <p:cNvPr id="9" name="chip-texto-113"/>
           <p:cNvSpPr txBox="1"/>
           <p:nvPr/>
         </p:nvSpPr>
@@ -11280,7 +11684,7 @@
       </p:sp>
       <p:sp>
         <p:nvSpPr>
-          <p:cNvPr id="10" name="chip-113"/>
+          <p:cNvPr id="10" name="chip-114"/>
           <p:cNvSpPr/>
           <p:nvPr/>
         </p:nvSpPr>
@@ -11302,7 +11706,7 @@
       </p:sp>
       <p:pic>
         <p:nvPicPr>
-          <p:cNvPr id="11" name="verificado-114" descr="Verificado">    </p:cNvPr>
+          <p:cNvPr id="11" name="verificado-115" descr="Verificado">    </p:cNvPr>
           <p:cNvPicPr>
             <a:picLocks noChangeAspect="1"/>
           </p:cNvPicPr>
@@ -11326,7 +11730,7 @@
       </p:pic>
       <p:sp>
         <p:nvSpPr>
-          <p:cNvPr id="12" name="chip-texto-115"/>
+          <p:cNvPr id="12" name="chip-texto-116"/>
           <p:cNvSpPr txBox="1"/>
           <p:nvPr/>
         </p:nvSpPr>
@@ -11362,7 +11766,7 @@
       </p:sp>
       <p:sp>
         <p:nvSpPr>
-          <p:cNvPr id="13" name="chip-116"/>
+          <p:cNvPr id="13" name="chip-117"/>
           <p:cNvSpPr/>
           <p:nvPr/>
         </p:nvSpPr>
@@ -11384,7 +11788,7 @@
       </p:sp>
       <p:sp>
         <p:nvSpPr>
-          <p:cNvPr id="14" name="chip-texto-117"/>
+          <p:cNvPr id="14" name="chip-texto-118"/>
           <p:cNvSpPr txBox="1"/>
           <p:nvPr/>
         </p:nvSpPr>
@@ -11420,7 +11824,7 @@
       </p:sp>
       <p:sp>
         <p:nvSpPr>
-          <p:cNvPr id="15" name="chip-118"/>
+          <p:cNvPr id="15" name="chip-119"/>
           <p:cNvSpPr/>
           <p:nvPr/>
         </p:nvSpPr>
@@ -11442,7 +11846,7 @@
       </p:sp>
       <p:sp>
         <p:nvSpPr>
-          <p:cNvPr id="16" name="chip-texto-119"/>
+          <p:cNvPr id="16" name="chip-texto-120"/>
           <p:cNvSpPr txBox="1"/>
           <p:nvPr/>
         </p:nvSpPr>
@@ -11478,7 +11882,7 @@
       </p:sp>
       <p:sp>
         <p:nvSpPr>
-          <p:cNvPr id="17" name="chip-120"/>
+          <p:cNvPr id="17" name="chip-121"/>
           <p:cNvSpPr/>
           <p:nvPr/>
         </p:nvSpPr>
@@ -11500,7 +11904,7 @@
       </p:sp>
       <p:sp>
         <p:nvSpPr>
-          <p:cNvPr id="18" name="chip-texto-121"/>
+          <p:cNvPr id="18" name="chip-texto-122"/>
           <p:cNvSpPr txBox="1"/>
           <p:nvPr/>
         </p:nvSpPr>
@@ -11536,7 +11940,7 @@
       </p:sp>
       <p:sp>
         <p:nvSpPr>
-          <p:cNvPr id="19" name="chip-122"/>
+          <p:cNvPr id="19" name="chip-123"/>
           <p:cNvSpPr/>
           <p:nvPr/>
         </p:nvSpPr>
@@ -11558,7 +11962,7 @@
       </p:sp>
       <p:sp>
         <p:nvSpPr>
-          <p:cNvPr id="20" name="chip-texto-123"/>
+          <p:cNvPr id="20" name="chip-texto-124"/>
           <p:cNvSpPr txBox="1"/>
           <p:nvPr/>
         </p:nvSpPr>
@@ -11594,7 +11998,7 @@
       </p:sp>
       <p:sp>
         <p:nvSpPr>
-          <p:cNvPr id="21" name="chip-124"/>
+          <p:cNvPr id="21" name="chip-125"/>
           <p:cNvSpPr/>
           <p:nvPr/>
         </p:nvSpPr>
@@ -11616,7 +12020,7 @@
       </p:sp>
       <p:sp>
         <p:nvSpPr>
-          <p:cNvPr id="22" name="chip-texto-125"/>
+          <p:cNvPr id="22" name="chip-texto-126"/>
           <p:cNvSpPr txBox="1"/>
           <p:nvPr/>
         </p:nvSpPr>
@@ -11652,7 +12056,7 @@
       </p:sp>
       <p:sp>
         <p:nvSpPr>
-          <p:cNvPr id="23" name="chip-126"/>
+          <p:cNvPr id="23" name="chip-127"/>
           <p:cNvSpPr/>
           <p:nvPr/>
         </p:nvSpPr>
@@ -11674,7 +12078,7 @@
       </p:sp>
       <p:sp>
         <p:nvSpPr>
-          <p:cNvPr id="24" name="chip-texto-127"/>
+          <p:cNvPr id="24" name="chip-texto-128"/>
           <p:cNvSpPr txBox="1"/>
           <p:nvPr/>
         </p:nvSpPr>
@@ -11710,7 +12114,7 @@
       </p:sp>
       <p:sp>
         <p:nvSpPr>
-          <p:cNvPr id="25" name="chip-128"/>
+          <p:cNvPr id="25" name="chip-129"/>
           <p:cNvSpPr/>
           <p:nvPr/>
         </p:nvSpPr>
@@ -11732,7 +12136,7 @@
       </p:sp>
       <p:sp>
         <p:nvSpPr>
-          <p:cNvPr id="26" name="chip-texto-129"/>
+          <p:cNvPr id="26" name="chip-texto-130"/>
           <p:cNvSpPr txBox="1"/>
           <p:nvPr/>
         </p:nvSpPr>
@@ -11768,7 +12172,7 @@
       </p:sp>
       <p:sp>
         <p:nvSpPr>
-          <p:cNvPr id="27" name="chip-130"/>
+          <p:cNvPr id="27" name="chip-131"/>
           <p:cNvSpPr/>
           <p:nvPr/>
         </p:nvSpPr>
@@ -11790,7 +12194,7 @@
       </p:sp>
       <p:sp>
         <p:nvSpPr>
-          <p:cNvPr id="28" name="chip-texto-131"/>
+          <p:cNvPr id="28" name="chip-texto-132"/>
           <p:cNvSpPr txBox="1"/>
           <p:nvPr/>
         </p:nvSpPr>
@@ -11886,7 +12290,7 @@
       </p:sp>
       <p:sp>
         <p:nvSpPr>
-          <p:cNvPr id="31" name="tarjeta-132"/>
+          <p:cNvPr id="31" name="tarjeta-133"/>
           <p:cNvSpPr/>
           <p:nvPr/>
         </p:nvSpPr>
@@ -11944,7 +12348,7 @@
       </p:sp>
       <p:sp>
         <p:nvSpPr>
-          <p:cNvPr id="33" name="icono-fondo-133"/>
+          <p:cNvPr id="33" name="icono-fondo-134"/>
           <p:cNvSpPr/>
           <p:nvPr/>
         </p:nvSpPr>
@@ -11966,7 +12370,7 @@
       </p:sp>
       <p:pic>
         <p:nvPicPr>
-          <p:cNvPr id="34" name="icono-LuSmartphone-134" descr="preencoded.png">    </p:cNvPr>
+          <p:cNvPr id="34" name="icono-LuSmartphone-135" descr="preencoded.png">    </p:cNvPr>
           <p:cNvPicPr>
             <a:picLocks noChangeAspect="1"/>
           </p:cNvPicPr>
@@ -11990,7 +12394,7 @@
       </p:pic>
       <p:sp>
         <p:nvSpPr>
-          <p:cNvPr id="35" name="texto-135"/>
+          <p:cNvPr id="35" name="texto-136"/>
           <p:cNvSpPr txBox="1"/>
           <p:nvPr/>
         </p:nvSpPr>
@@ -12043,7 +12447,7 @@
       </p:sp>
       <p:sp>
         <p:nvSpPr>
-          <p:cNvPr id="36" name="icono-fondo-136"/>
+          <p:cNvPr id="36" name="icono-fondo-137"/>
           <p:cNvSpPr/>
           <p:nvPr/>
         </p:nvSpPr>
@@ -12065,7 +12469,7 @@
       </p:sp>
       <p:pic>
         <p:nvPicPr>
-          <p:cNvPr id="37" name="icono-LuMonitorSmartphone-137" descr="preencoded.png">    </p:cNvPr>
+          <p:cNvPr id="37" name="icono-LuMonitorSmartphone-138" descr="preencoded.png">    </p:cNvPr>
           <p:cNvPicPr>
             <a:picLocks noChangeAspect="1"/>
           </p:cNvPicPr>
@@ -12089,7 +12493,7 @@
       </p:pic>
       <p:sp>
         <p:nvSpPr>
-          <p:cNvPr id="38" name="texto-138"/>
+          <p:cNvPr id="38" name="texto-139"/>
           <p:cNvSpPr txBox="1"/>
           <p:nvPr/>
         </p:nvSpPr>
@@ -12142,7 +12546,7 @@
       </p:sp>
       <p:sp>
         <p:nvSpPr>
-          <p:cNvPr id="39" name="icono-fondo-139"/>
+          <p:cNvPr id="39" name="icono-fondo-140"/>
           <p:cNvSpPr/>
           <p:nvPr/>
         </p:nvSpPr>
@@ -12164,7 +12568,7 @@
       </p:sp>
       <p:pic>
         <p:nvPicPr>
-          <p:cNvPr id="40" name="icono-LuLaptop-140" descr="preencoded.png">    </p:cNvPr>
+          <p:cNvPr id="40" name="icono-LuLaptop-141" descr="preencoded.png">    </p:cNvPr>
           <p:cNvPicPr>
             <a:picLocks noChangeAspect="1"/>
           </p:cNvPicPr>
@@ -12188,7 +12592,7 @@
       </p:pic>
       <p:sp>
         <p:nvSpPr>
-          <p:cNvPr id="41" name="texto-141"/>
+          <p:cNvPr id="41" name="texto-142"/>
           <p:cNvSpPr txBox="1"/>
           <p:nvPr/>
         </p:nvSpPr>

</xml_diff>

<commit_message>
Presentación: nombre Presentazo y estado actual del proyecto
- Todo el contenido usa el nuevo nombre.
- La hoja de ruta pasa a «Lo que ya está listo y lo que sigue»: Cloudflare,
  protección de costos, QR por sesión y control web ya disponibles.
- Calidad: 42 pruebas y conexión verificada en redes de empresa.

Co-Authored-By: Claude Opus 5.5 <noreply@anthropic.com>
</commit_message>
<xml_diff>
--- a/presentacion/mando.pptx
+++ b/presentacion/mando.pptx
@@ -121,7 +121,7 @@
   <p:extLst>
     <p:ext uri="{521415D9-36F7-43E2-AB2F-B90AF26B5E84}">
       <p14:sectionLst xmlns:p14="http://schemas.microsoft.com/office/powerpoint/2010/main">
-        <p14:section name="Introducción" id="{06db4df0-0b89-3d8a-8a21-2f684eb23efb}">
+        <p14:section name="Introducción" id="{95793fad-9825-39e2-ec6e-f81686b1b5fd}">
           <p14:sldIdLst>
             <p14:sldId id="256"/>
             <p14:sldId id="257"/>
@@ -129,27 +129,27 @@
             <p14:sldId id="259"/>
           </p14:sldIdLst>
         </p14:section>
-        <p14:section name="Funciones" id="{c196b939-49c5-fca3-f3e2-cad589d2b8c8}">
+        <p14:section name="Funciones" id="{4de36e3f-f06f-2548-7027-682465533058}">
           <p14:sldIdLst>
             <p14:sldId id="260"/>
             <p14:sldId id="261"/>
             <p14:sldId id="262"/>
           </p14:sldIdLst>
         </p14:section>
-        <p14:section name="Valor" id="{552fc145-2c25-bfea-19c9-1c515cfce813}">
+        <p14:section name="Valor" id="{f17600f2-e6ee-45ea-2607-614e9a65286c}">
           <p14:sldIdLst>
             <p14:sldId id="263"/>
             <p14:sldId id="264"/>
           </p14:sldIdLst>
         </p14:section>
-        <p14:section name="Tecnología" id="{dcec37d4-004a-6025-fbc3-056e0e3a43af}">
+        <p14:section name="Tecnología" id="{79f2e2a7-ea93-2022-43e2-16701c791e30}">
           <p14:sldIdLst>
             <p14:sldId id="265"/>
             <p14:sldId id="266"/>
             <p14:sldId id="267"/>
           </p14:sldIdLst>
         </p14:section>
-        <p14:section name="Cierre" id="{c957a61e-37c1-aac5-90f1-28f1f74aab92}">
+        <p14:section name="Cierre" id="{2a9e87be-c8fc-523e-ffd4-48945e44dbb5}">
           <p14:sldIdLst>
             <p14:sldId id="268"/>
             <p14:sldId id="269"/>
@@ -560,7 +560,7 @@
           <a:p>
             <a:r>
               <a:rPr lang="en-US" dirty="0"/>
-              <a:t>Mando es una extensión de Chrome que convierte el celular en el control remoto de cualquier presentación: avanzar diapositivas, puntero láser, lápiz, mouse y teclado. Se conecta escaneando un código QR, sin instalar apps.</a:t>
+              <a:t>Presentazo es una extensión de Chrome que convierte el celular en el control remoto de cualquier presentación: avanzar diapositivas, puntero láser, lápiz, mouse y teclado. Se conecta escaneando un código QR, sin instalar apps.</a:t>
             </a:r>
             <a:endParaRPr lang="en-US" dirty="0"/>
           </a:p>
@@ -824,7 +824,7 @@
           <a:p>
             <a:r>
               <a:rPr lang="en-US" dirty="0"/>
-              <a:t>Mando se probó de punta a punta con pruebas automáticas que conectan la extensión y el celular de verdad: 42 de 42 comprobaciones superadas. La interfaz se revisó en 28 combinaciones de pantalla y vista. Si se corta el servidor, se reconecta solo en unos 3 segundos sin desconectar al celular.</a:t>
+              <a:t>Presentazo se probó de punta a punta con pruebas automáticas que conectan la extensión y el celular de verdad: 42 de 42 comprobaciones superadas. La interfaz se revisó en 28 combinaciones de pantalla y vista. Si se corta el servidor, se reconecta solo en unos 3 segundos sin desconectar al celular.</a:t>
             </a:r>
             <a:endParaRPr lang="en-US" dirty="0"/>
           </a:p>
@@ -912,7 +912,7 @@
           <a:p>
             <a:r>
               <a:rPr lang="en-US" dirty="0"/>
-              <a:t>Hoy hay tres límites conocidos: se necesita internet para enlazar los dispositivos, Chrome no permite extensiones en sus páginas internas, y Mando no controla programas fuera del navegador. Ya están listos la retransmisión con Cloudflare para redes restrictivas y el QR nuevo en cada sesión. La versión 1.0 está en revisión en la Chrome Web Store y la 1.1 está preparada; queda por evaluar una app para Apple Watch.</a:t>
+              <a:t>Varias metas ya están cumplidas: la retransmisión con Cloudflare para redes de empresa, la protección de costos que pausa el servicio antes de pasar la cuota gratuita, el código QR nuevo en cada sesión y el control web publicado. Lo que sigue es la aprobación en la Chrome Web Store, donde la versión 1.1 llegará con el nuevo nombre Presentazo, y evaluar una app para Apple Watch. Los límites que se mantienen son técnicos: se necesita internet, y Chrome no permite extensiones en sus páginas internas.</a:t>
             </a:r>
             <a:endParaRPr lang="en-US" dirty="0"/>
           </a:p>
@@ -1000,7 +1000,7 @@
           <a:p>
             <a:r>
               <a:rPr lang="en-US" dirty="0"/>
-              <a:t>Mando permite presentar con libertad: escanear, conectar y presentar desde el celular. El código QR de la diapositiva lleva al repositorio en GitHub, donde está todo el proyecto.</a:t>
+              <a:t>Presentazo permite presentar con libertad: escanear, conectar y presentar desde el celular. El código QR de la diapositiva lleva al repositorio en GitHub, donde está todo el proyecto.</a:t>
             </a:r>
             <a:endParaRPr lang="en-US" dirty="0"/>
           </a:p>
@@ -1352,7 +1352,7 @@
           <a:p>
             <a:r>
               <a:rPr lang="en-US" dirty="0"/>
-              <a:t>Paso 1: abrir la presentación en Chrome. Paso 2: hacer clic en el ícono de Mando o pulsar Alt+Shift+M y escanear el QR con la cámara. Paso 3: presentar desde el celular. Por seguridad, cada sesión genera un código QR nuevo.</a:t>
+              <a:t>Paso 1: abrir la presentación en Chrome. Paso 2: hacer clic en el ícono de Presentazo o pulsar Alt+Shift+M y escanear el QR con la cámara. Paso 3: presentar desde el celular. Por seguridad, cada sesión genera un código QR nuevo.</a:t>
             </a:r>
             <a:endParaRPr lang="en-US" dirty="0"/>
           </a:p>
@@ -1792,7 +1792,7 @@
           <a:p>
             <a:r>
               <a:rPr lang="en-US" dirty="0"/>
-              <a:t>Mando funciona con cualquier presentación que avance con el teclado. Google Slides y reveal.js se verificaron con presentaciones reales. El control funciona en celulares desde 320 píxeles y en tablets; en la computadora se necesita Google Chrome.</a:t>
+              <a:t>Presentazo funciona con cualquier presentación que avance con el teclado. Google Slides y reveal.js se verificaron con presentaciones reales. El control funciona en celulares desde 320 píxeles y en tablets; en la computadora se necesita Google Chrome.</a:t>
             </a:r>
             <a:endParaRPr lang="en-US" dirty="0"/>
           </a:p>
@@ -1899,7 +1899,7 @@
         <p:spPr>
           <a:xfrm>
             <a:off x="822960" y="2788920"/>
-            <a:ext cx="4937760" cy="1051560"/>
+            <a:ext cx="5257800" cy="1051560"/>
           </a:xfrm>
           <a:prstGeom prst="rect">
             <a:avLst/>
@@ -1912,7 +1912,7 @@
           <a:lstStyle>
             <a:lvl1pPr algn="l" indent="0" marL="0">
               <a:buNone/>
-              <a:defRPr lang="en-US" sz="6600" b="1" dirty="0">
+              <a:defRPr lang="en-US" sz="6000" b="1" dirty="0">
                 <a:solidFill>
                   <a:schemeClr val="bg1"/>
                 </a:solidFill>
@@ -1923,7 +1923,7 @@
             <a:pPr algn="l" indent="0" marL="0">
               <a:buNone/>
             </a:pPr>
-            <a:endParaRPr lang="en-US" sz="6600" dirty="0"/>
+            <a:endParaRPr lang="en-US" sz="6000" dirty="0"/>
           </a:p>
         </p:txBody>
       </p:sp>
@@ -2145,7 +2145,7 @@
                   <a:schemeClr val="accent6"/>
                 </a:solidFill>
               </a:rPr>
-              <a:t>Mando · Control remoto de presentaciones</a:t>
+              <a:t>Presentazo · Control remoto de presentaciones</a:t>
             </a:r>
             <a:endParaRPr lang="en-US" sz="1000" dirty="0"/>
           </a:p>
@@ -2336,7 +2336,7 @@
                   <a:schemeClr val="accent5"/>
                 </a:solidFill>
               </a:rPr>
-              <a:t>Mando · Control remoto de presentaciones</a:t>
+              <a:t>Presentazo · Control remoto de presentaciones</a:t>
             </a:r>
             <a:endParaRPr lang="en-US" sz="1000" dirty="0"/>
           </a:p>
@@ -2850,7 +2850,7 @@
       </p:grpSpPr>
       <p:pic>
         <p:nvPicPr>
-          <p:cNvPr id="2" name="logo" descr="Logo de Mando">    </p:cNvPr>
+          <p:cNvPr id="2" name="logo" descr="Logo de Presentazo">    </p:cNvPr>
           <p:cNvPicPr>
             <a:picLocks noChangeAspect="1"/>
           </p:cNvPicPr>
@@ -2883,7 +2883,7 @@
         <p:spPr>
           <a:xfrm>
             <a:off x="822960" y="2788920"/>
-            <a:ext cx="4937760" cy="1051560"/>
+            <a:ext cx="5257800" cy="1051560"/>
           </a:xfrm>
           <a:prstGeom prst="rect">
             <a:avLst/>
@@ -2899,14 +2899,14 @@
               <a:buNone/>
             </a:pPr>
             <a:r>
-              <a:rPr lang="en-US" sz="6600" b="1" dirty="0">
+              <a:rPr lang="en-US" sz="6000" b="1" dirty="0">
                 <a:solidFill>
                   <a:schemeClr val="bg1"/>
                 </a:solidFill>
               </a:rPr>
-              <a:t>Mando</a:t>
-            </a:r>
-            <a:endParaRPr lang="en-US" sz="6600" dirty="0"/>
+              <a:t>Presentazo</a:t>
+            </a:r>
+            <a:endParaRPr lang="en-US" sz="6000" dirty="0"/>
           </a:p>
         </p:txBody>
       </p:sp>
@@ -3013,7 +3013,7 @@
       </p:sp>
       <p:pic>
         <p:nvPicPr>
-          <p:cNvPr id="7" name="captura-2" descr="Diapositiva con el puntero láser de Mando">    </p:cNvPr>
+          <p:cNvPr id="7" name="captura-2" descr="Diapositiva con el puntero láser de Presentazo">    </p:cNvPr>
           <p:cNvPicPr>
             <a:picLocks noChangeAspect="1"/>
           </p:cNvPicPr>
@@ -3037,7 +3037,7 @@
       </p:pic>
       <p:pic>
         <p:nvPicPr>
-          <p:cNvPr id="8" name="celular-3" descr="Control de Mando en el celular">    </p:cNvPr>
+          <p:cNvPr id="8" name="celular-3" descr="Control de Presentazo en el celular">    </p:cNvPr>
           <p:cNvPicPr>
             <a:picLocks noChangeAspect="1"/>
           </p:cNvPicPr>
@@ -3609,7 +3609,7 @@
                   <a:schemeClr val="accent6"/>
                 </a:solidFill>
               </a:rPr>
-              <a:t>Google Chrome con la extensión Mando.</a:t>
+              <a:t>Google Chrome con la extensión Presentazo.</a:t>
             </a:r>
             <a:endParaRPr lang="en-US" sz="1700" dirty="0"/>
           </a:p>
@@ -4304,7 +4304,7 @@
                   <a:schemeClr val="accent5"/>
                 </a:solidFill>
               </a:rPr>
-              <a:t>Los scripts de Mando se retiran de Chrome al detener la sesión.</a:t>
+              <a:t>Los scripts de Presentazo se retiran de Chrome al detener la sesión.</a:t>
             </a:r>
             <a:endParaRPr lang="en-US" sz="1700" dirty="0"/>
           </a:p>
@@ -5228,12 +5228,12 @@
         </p:nvSpPr>
         <p:spPr>
           <a:xfrm>
-            <a:off x="640080" y="4480560"/>
-            <a:ext cx="10911535" cy="1097280"/>
+            <a:off x="640080" y="4343400"/>
+            <a:ext cx="10911535" cy="1325880"/>
           </a:xfrm>
           <a:prstGeom prst="roundRect">
             <a:avLst>
-              <a:gd name="adj" fmla="val 13333"/>
+              <a:gd name="adj" fmla="val 11034"/>
             </a:avLst>
           </a:prstGeom>
           <a:solidFill>
@@ -5258,8 +5258,8 @@
         </p:blipFill>
         <p:spPr>
           <a:xfrm>
-            <a:off x="960120" y="4754880"/>
-            <a:ext cx="347472" cy="347472"/>
+            <a:off x="960120" y="4617720"/>
+            <a:ext cx="329184" cy="329184"/>
           </a:xfrm>
           <a:prstGeom prst="rect">
             <a:avLst/>
@@ -5274,8 +5274,8 @@
         </p:nvSpPr>
         <p:spPr>
           <a:xfrm>
-            <a:off x="1508760" y="4690872"/>
-            <a:ext cx="4495648" cy="777240"/>
+            <a:off x="1463040" y="4553712"/>
+            <a:ext cx="2692298" cy="1051560"/>
           </a:xfrm>
           <a:prstGeom prst="rect">
             <a:avLst/>
@@ -5294,28 +5294,28 @@
               <a:buNone/>
             </a:pPr>
             <a:r>
-              <a:rPr lang="en-US" sz="1600" b="1" dirty="0">
+              <a:rPr lang="en-US" sz="1500" b="1" dirty="0">
                 <a:solidFill>
                   <a:schemeClr val="tx1"/>
                 </a:solidFill>
               </a:rPr>
-              <a:t>Verificado con Google Slides y reveal.js reales</a:t>
-            </a:r>
-            <a:endParaRPr lang="en-US" sz="1600" dirty="0"/>
-          </a:p>
-          <a:p>
-            <a:pPr indent="0" marL="0">
-              <a:buNone/>
-            </a:pPr>
-            <a:r>
-              <a:rPr lang="en-US" sz="1400" dirty="0">
+              <a:t>Google Slides y reveal.js reales</a:t>
+            </a:r>
+            <a:endParaRPr lang="en-US" sz="1500" dirty="0"/>
+          </a:p>
+          <a:p>
+            <a:pPr indent="0" marL="0">
+              <a:buNone/>
+            </a:pPr>
+            <a:r>
+              <a:rPr lang="en-US" sz="1300" dirty="0">
                 <a:solidFill>
                   <a:schemeClr val="accent6"/>
                 </a:solidFill>
               </a:rPr>
-              <a:t>Iniciar la presentación, avanzar, retroceder y salir.</a:t>
-            </a:r>
-            <a:endParaRPr lang="en-US" sz="1600" dirty="0"/>
+              <a:t>Iniciar, avanzar, retroceder y salir.</a:t>
+            </a:r>
+            <a:endParaRPr lang="en-US" sz="1500" dirty="0"/>
           </a:p>
         </p:txBody>
       </p:sp>
@@ -5335,8 +5335,8 @@
         </p:blipFill>
         <p:spPr>
           <a:xfrm>
-            <a:off x="6415888" y="4754880"/>
-            <a:ext cx="347472" cy="347472"/>
+            <a:off x="4475378" y="4617720"/>
+            <a:ext cx="329184" cy="329184"/>
           </a:xfrm>
           <a:prstGeom prst="rect">
             <a:avLst/>
@@ -5351,8 +5351,8 @@
         </p:nvSpPr>
         <p:spPr>
           <a:xfrm>
-            <a:off x="6964528" y="4690872"/>
-            <a:ext cx="4495648" cy="777240"/>
+            <a:off x="4978298" y="4553712"/>
+            <a:ext cx="2692298" cy="1051560"/>
           </a:xfrm>
           <a:prstGeom prst="rect">
             <a:avLst/>
@@ -5371,28 +5371,105 @@
               <a:buNone/>
             </a:pPr>
             <a:r>
-              <a:rPr lang="en-US" sz="1600" b="1" dirty="0">
+              <a:rPr lang="en-US" sz="1500" b="1" dirty="0">
                 <a:solidFill>
                   <a:schemeClr val="tx1"/>
                 </a:solidFill>
               </a:rPr>
+              <a:t>Redes de empresa</a:t>
+            </a:r>
+            <a:endParaRPr lang="en-US" sz="1500" dirty="0"/>
+          </a:p>
+          <a:p>
+            <a:pPr indent="0" marL="0">
+              <a:buNone/>
+            </a:pPr>
+            <a:r>
+              <a:rPr lang="en-US" sz="1300" dirty="0">
+                <a:solidFill>
+                  <a:schemeClr val="accent6"/>
+                </a:solidFill>
+              </a:rPr>
+              <a:t>Conecta por Cloudflare incluso solo con el puerto 443.</a:t>
+            </a:r>
+            <a:endParaRPr lang="en-US" sz="1500" dirty="0"/>
+          </a:p>
+        </p:txBody>
+      </p:sp>
+      <p:pic>
+        <p:nvPicPr>
+          <p:cNvPr id="17" name="check-195" descr="preencoded.png">    </p:cNvPr>
+          <p:cNvPicPr>
+            <a:picLocks noChangeAspect="1"/>
+          </p:cNvPicPr>
+          <p:nvPr/>
+        </p:nvPicPr>
+        <p:blipFill>
+          <a:blip r:embed="rId3"/>
+          <a:stretch>
+            <a:fillRect/>
+          </a:stretch>
+        </p:blipFill>
+        <p:spPr>
+          <a:xfrm>
+            <a:off x="7990637" y="4617720"/>
+            <a:ext cx="329184" cy="329184"/>
+          </a:xfrm>
+          <a:prstGeom prst="rect">
+            <a:avLst/>
+          </a:prstGeom>
+        </p:spPr>
+      </p:pic>
+      <p:sp>
+        <p:nvSpPr>
+          <p:cNvPr id="18" name="texto-196"/>
+          <p:cNvSpPr txBox="1"/>
+          <p:nvPr/>
+        </p:nvSpPr>
+        <p:spPr>
+          <a:xfrm>
+            <a:off x="8493557" y="4553712"/>
+            <a:ext cx="2692298" cy="1051560"/>
+          </a:xfrm>
+          <a:prstGeom prst="rect">
+            <a:avLst/>
+          </a:prstGeom>
+          <a:noFill/>
+          <a:ln/>
+        </p:spPr>
+        <p:txBody>
+          <a:bodyPr wrap="square" lIns="0" tIns="0" rIns="0" bIns="0" rtlCol="0" anchor="t"/>
+          <a:lstStyle/>
+          <a:p>
+            <a:pPr indent="0" marL="0">
+              <a:spcAft>
+                <a:spcPts val="300"/>
+              </a:spcAft>
+              <a:buNone/>
+            </a:pPr>
+            <a:r>
+              <a:rPr lang="en-US" sz="1500" b="1" dirty="0">
+                <a:solidFill>
+                  <a:schemeClr val="tx1"/>
+                </a:solidFill>
+              </a:rPr>
               <a:t>Código QR fácil de escanear</a:t>
             </a:r>
-            <a:endParaRPr lang="en-US" sz="1600" dirty="0"/>
-          </a:p>
-          <a:p>
-            <a:pPr indent="0" marL="0">
-              <a:buNone/>
-            </a:pPr>
-            <a:r>
-              <a:rPr lang="en-US" sz="1400" dirty="0">
+            <a:endParaRPr lang="en-US" sz="1500" dirty="0"/>
+          </a:p>
+          <a:p>
+            <a:pPr indent="0" marL="0">
+              <a:buNone/>
+            </a:pPr>
+            <a:r>
+              <a:rPr lang="en-US" sz="1300" dirty="0">
                 <a:solidFill>
                   <a:schemeClr val="accent6"/>
                 </a:solidFill>
               </a:rPr>
-              <a:t>Se lee correctamente incluso reducido al 30 % de su tamaño.</a:t>
-            </a:r>
-            <a:endParaRPr lang="en-US" sz="1600" dirty="0"/>
+              <a:t>Se lee incluso reducido al 30 % de su tamaño.</a:t>
+            </a:r>
+            <a:endParaRPr lang="en-US" sz="1500" dirty="0"/>
           </a:p>
         </p:txBody>
       </p:sp>
@@ -5498,7 +5575,7 @@
                   <a:schemeClr val="accent1"/>
                 </a:solidFill>
               </a:rPr>
-              <a:t>HOJA DE RUTA</a:t>
+              <a:t>ESTADO DEL PROYECTO</a:t>
             </a:r>
             <a:endParaRPr lang="en-US" sz="1200" dirty="0"/>
           </a:p>
@@ -5536,7 +5613,7 @@
                   <a:schemeClr val="tx1"/>
                 </a:solidFill>
               </a:rPr>
-              <a:t>Límites actuales y próximos pasos</a:t>
+              <a:t>Lo que ya está listo y lo que sigue</a:t>
             </a:r>
             <a:endParaRPr lang="en-US" sz="3600" dirty="0"/>
           </a:p>
@@ -5544,18 +5621,18 @@
       </p:sp>
       <p:sp>
         <p:nvSpPr>
-          <p:cNvPr id="4" name="tarjeta-195"/>
+          <p:cNvPr id="4" name="tarjeta-197"/>
           <p:cNvSpPr/>
           <p:nvPr/>
         </p:nvSpPr>
         <p:spPr>
           <a:xfrm>
             <a:off x="640080" y="1783080"/>
-            <a:ext cx="5300320" cy="4297680"/>
+            <a:ext cx="5300320" cy="3794760"/>
           </a:xfrm>
           <a:prstGeom prst="roundRect">
             <a:avLst>
-              <a:gd name="adj" fmla="val 3404"/>
+              <a:gd name="adj" fmla="val 3855"/>
             </a:avLst>
           </a:prstGeom>
           <a:solidFill>
@@ -5566,29 +5643,63 @@
       </p:sp>
       <p:sp>
         <p:nvSpPr>
-          <p:cNvPr id="5" name="icono-fondo-196"/>
-          <p:cNvSpPr/>
-          <p:nvPr/>
-        </p:nvSpPr>
-        <p:spPr>
-          <a:xfrm>
-            <a:off x="960120" y="2011680"/>
-            <a:ext cx="502920" cy="502920"/>
-          </a:xfrm>
-          <a:prstGeom prst="roundRect">
-            <a:avLst>
-              <a:gd name="adj" fmla="val 26000"/>
-            </a:avLst>
+          <p:cNvPr id="5" name="listo"/>
+          <p:cNvSpPr txBox="1"/>
+          <p:nvPr/>
+        </p:nvSpPr>
+        <p:spPr>
+          <a:xfrm>
+            <a:off x="960120" y="1965960"/>
+            <a:ext cx="4660240" cy="457200"/>
+          </a:xfrm>
+          <a:prstGeom prst="rect">
+            <a:avLst/>
+          </a:prstGeom>
+          <a:noFill/>
+          <a:ln/>
+        </p:spPr>
+        <p:txBody>
+          <a:bodyPr wrap="square" lIns="0" tIns="0" rIns="0" bIns="0" rtlCol="0" anchor="ctr"/>
+          <a:lstStyle/>
+          <a:p>
+            <a:pPr indent="0" marL="0">
+              <a:buNone/>
+            </a:pPr>
+            <a:r>
+              <a:rPr lang="en-US" sz="1800" b="1" dirty="0">
+                <a:solidFill>
+                  <a:schemeClr val="tx1"/>
+                </a:solidFill>
+              </a:rPr>
+              <a:t>Ya disponible</a:t>
+            </a:r>
+            <a:endParaRPr lang="en-US" sz="1800" dirty="0"/>
+          </a:p>
+        </p:txBody>
+      </p:sp>
+      <p:sp>
+        <p:nvSpPr>
+          <p:cNvPr id="6" name="hecho-198"/>
+          <p:cNvSpPr/>
+          <p:nvPr/>
+        </p:nvSpPr>
+        <p:spPr>
+          <a:xfrm>
+            <a:off x="960120" y="2578608"/>
+            <a:ext cx="402336" cy="402336"/>
+          </a:xfrm>
+          <a:prstGeom prst="ellipse">
+            <a:avLst/>
           </a:prstGeom>
           <a:solidFill>
-            <a:schemeClr val="accent6"/>
+            <a:schemeClr val="accent2"/>
           </a:solidFill>
           <a:ln/>
         </p:spPr>
       </p:sp>
       <p:pic>
         <p:nvPicPr>
-          <p:cNvPr id="6" name="icono-LuTriangleAlert-197" descr="preencoded.png">    </p:cNvPr>
+          <p:cNvPr id="7" name="hecho-icono-199" descr="preencoded.png">    </p:cNvPr>
           <p:cNvPicPr>
             <a:picLocks noChangeAspect="1"/>
           </p:cNvPicPr>
@@ -5602,8 +5713,8 @@
         </p:blipFill>
         <p:spPr>
           <a:xfrm>
-            <a:off x="1080821" y="2132381"/>
-            <a:ext cx="261518" cy="261518"/>
+            <a:off x="1042416" y="2660904"/>
+            <a:ext cx="237744" cy="237744"/>
           </a:xfrm>
           <a:prstGeom prst="rect">
             <a:avLst/>
@@ -5612,70 +5723,14 @@
       </p:pic>
       <p:sp>
         <p:nvSpPr>
-          <p:cNvPr id="7" name="limites"/>
+          <p:cNvPr id="8" name="texto-200"/>
           <p:cNvSpPr txBox="1"/>
           <p:nvPr/>
         </p:nvSpPr>
         <p:spPr>
           <a:xfrm>
-            <a:off x="1645920" y="2011680"/>
-            <a:ext cx="4020160" cy="502920"/>
-          </a:xfrm>
-          <a:prstGeom prst="rect">
-            <a:avLst/>
-          </a:prstGeom>
-          <a:noFill/>
-          <a:ln/>
-        </p:spPr>
-        <p:txBody>
-          <a:bodyPr wrap="square" lIns="0" tIns="0" rIns="0" bIns="0" rtlCol="0" anchor="ctr"/>
-          <a:lstStyle/>
-          <a:p>
-            <a:pPr indent="0" marL="0">
-              <a:buNone/>
-            </a:pPr>
-            <a:r>
-              <a:rPr lang="en-US" sz="1800" b="1" dirty="0">
-                <a:solidFill>
-                  <a:schemeClr val="tx1"/>
-                </a:solidFill>
-              </a:rPr>
-              <a:t>Límites actuales</a:t>
-            </a:r>
-            <a:endParaRPr lang="en-US" sz="1800" dirty="0"/>
-          </a:p>
-        </p:txBody>
-      </p:sp>
-      <p:sp>
-        <p:nvSpPr>
-          <p:cNvPr id="8" name="punto-198"/>
-          <p:cNvSpPr/>
-          <p:nvPr/>
-        </p:nvSpPr>
-        <p:spPr>
-          <a:xfrm>
-            <a:off x="1024128" y="2880360"/>
-            <a:ext cx="128016" cy="128016"/>
-          </a:xfrm>
-          <a:prstGeom prst="ellipse">
-            <a:avLst/>
-          </a:prstGeom>
-          <a:solidFill>
-            <a:schemeClr val="accent6"/>
-          </a:solidFill>
-          <a:ln/>
-        </p:spPr>
-      </p:sp>
-      <p:sp>
-        <p:nvSpPr>
-          <p:cNvPr id="9" name="texto-199"/>
-          <p:cNvSpPr txBox="1"/>
-          <p:nvPr/>
-        </p:nvSpPr>
-        <p:spPr>
-          <a:xfrm>
-            <a:off x="1371600" y="2788920"/>
-            <a:ext cx="4248760" cy="960120"/>
+            <a:off x="1536192" y="2542032"/>
+            <a:ext cx="4111600" cy="713232"/>
           </a:xfrm>
           <a:prstGeom prst="rect">
             <a:avLst/>
@@ -5694,228 +5749,44 @@
               <a:buNone/>
             </a:pPr>
             <a:r>
-              <a:rPr lang="en-US" sz="1600" b="1" dirty="0">
+              <a:rPr lang="en-US" sz="1500" b="1" dirty="0">
                 <a:solidFill>
                   <a:schemeClr val="tx1"/>
                 </a:solidFill>
               </a:rPr>
-              <a:t>Necesita internet</a:t>
-            </a:r>
-            <a:endParaRPr lang="en-US" sz="1600" dirty="0"/>
-          </a:p>
-          <a:p>
-            <a:pPr indent="0" marL="0">
-              <a:buNone/>
-            </a:pPr>
-            <a:r>
-              <a:rPr lang="en-US" sz="1400" dirty="0">
+              <a:t>Retransmisión con Cloudflare</a:t>
+            </a:r>
+            <a:endParaRPr lang="en-US" sz="1500" dirty="0"/>
+          </a:p>
+          <a:p>
+            <a:pPr indent="0" marL="0">
+              <a:buNone/>
+            </a:pPr>
+            <a:r>
+              <a:rPr lang="en-US" sz="1300" dirty="0">
                 <a:solidFill>
                   <a:schemeClr val="accent6"/>
                 </a:solidFill>
               </a:rPr>
-              <a:t>El celular y la computadora se enlazan a través de internet.</a:t>
-            </a:r>
-            <a:endParaRPr lang="en-US" sz="1600" dirty="0"/>
-          </a:p>
-        </p:txBody>
-      </p:sp>
-      <p:sp>
-        <p:nvSpPr>
-          <p:cNvPr id="10" name="punto-200"/>
-          <p:cNvSpPr/>
-          <p:nvPr/>
-        </p:nvSpPr>
-        <p:spPr>
-          <a:xfrm>
-            <a:off x="1024128" y="3959352"/>
-            <a:ext cx="128016" cy="128016"/>
+              <a:t>Conecta incluso en redes de empresa (puerto 443).</a:t>
+            </a:r>
+            <a:endParaRPr lang="en-US" sz="1500" dirty="0"/>
+          </a:p>
+        </p:txBody>
+      </p:sp>
+      <p:sp>
+        <p:nvSpPr>
+          <p:cNvPr id="9" name="hecho-201"/>
+          <p:cNvSpPr/>
+          <p:nvPr/>
+        </p:nvSpPr>
+        <p:spPr>
+          <a:xfrm>
+            <a:off x="960120" y="3310128"/>
+            <a:ext cx="402336" cy="402336"/>
           </a:xfrm>
           <a:prstGeom prst="ellipse">
             <a:avLst/>
-          </a:prstGeom>
-          <a:solidFill>
-            <a:schemeClr val="accent6"/>
-          </a:solidFill>
-          <a:ln/>
-        </p:spPr>
-      </p:sp>
-      <p:sp>
-        <p:nvSpPr>
-          <p:cNvPr id="11" name="texto-201"/>
-          <p:cNvSpPr txBox="1"/>
-          <p:nvPr/>
-        </p:nvSpPr>
-        <p:spPr>
-          <a:xfrm>
-            <a:off x="1371600" y="3867912"/>
-            <a:ext cx="4248760" cy="960120"/>
-          </a:xfrm>
-          <a:prstGeom prst="rect">
-            <a:avLst/>
-          </a:prstGeom>
-          <a:noFill/>
-          <a:ln/>
-        </p:spPr>
-        <p:txBody>
-          <a:bodyPr wrap="square" lIns="0" tIns="0" rIns="0" bIns="0" rtlCol="0" anchor="t"/>
-          <a:lstStyle/>
-          <a:p>
-            <a:pPr indent="0" marL="0">
-              <a:spcAft>
-                <a:spcPts val="300"/>
-              </a:spcAft>
-              <a:buNone/>
-            </a:pPr>
-            <a:r>
-              <a:rPr lang="en-US" sz="1600" b="1" dirty="0">
-                <a:solidFill>
-                  <a:schemeClr val="tx1"/>
-                </a:solidFill>
-              </a:rPr>
-              <a:t>Páginas protegidas de Chrome</a:t>
-            </a:r>
-            <a:endParaRPr lang="en-US" sz="1600" dirty="0"/>
-          </a:p>
-          <a:p>
-            <a:pPr indent="0" marL="0">
-              <a:buNone/>
-            </a:pPr>
-            <a:r>
-              <a:rPr lang="en-US" sz="1400" dirty="0">
-                <a:solidFill>
-                  <a:schemeClr val="accent6"/>
-                </a:solidFill>
-              </a:rPr>
-              <a:t>No funciona en chrome://, la Chrome Web Store ni el visor de PDF integrado.</a:t>
-            </a:r>
-            <a:endParaRPr lang="en-US" sz="1600" dirty="0"/>
-          </a:p>
-        </p:txBody>
-      </p:sp>
-      <p:sp>
-        <p:nvSpPr>
-          <p:cNvPr id="12" name="punto-202"/>
-          <p:cNvSpPr/>
-          <p:nvPr/>
-        </p:nvSpPr>
-        <p:spPr>
-          <a:xfrm>
-            <a:off x="1024128" y="5038344"/>
-            <a:ext cx="128016" cy="128016"/>
-          </a:xfrm>
-          <a:prstGeom prst="ellipse">
-            <a:avLst/>
-          </a:prstGeom>
-          <a:solidFill>
-            <a:schemeClr val="accent6"/>
-          </a:solidFill>
-          <a:ln/>
-        </p:spPr>
-      </p:sp>
-      <p:sp>
-        <p:nvSpPr>
-          <p:cNvPr id="13" name="texto-203"/>
-          <p:cNvSpPr txBox="1"/>
-          <p:nvPr/>
-        </p:nvSpPr>
-        <p:spPr>
-          <a:xfrm>
-            <a:off x="1371600" y="4946904"/>
-            <a:ext cx="4248760" cy="960120"/>
-          </a:xfrm>
-          <a:prstGeom prst="rect">
-            <a:avLst/>
-          </a:prstGeom>
-          <a:noFill/>
-          <a:ln/>
-        </p:spPr>
-        <p:txBody>
-          <a:bodyPr wrap="square" lIns="0" tIns="0" rIns="0" bIns="0" rtlCol="0" anchor="t"/>
-          <a:lstStyle/>
-          <a:p>
-            <a:pPr indent="0" marL="0">
-              <a:spcAft>
-                <a:spcPts val="300"/>
-              </a:spcAft>
-              <a:buNone/>
-            </a:pPr>
-            <a:r>
-              <a:rPr lang="en-US" sz="1600" b="1" dirty="0">
-                <a:solidFill>
-                  <a:schemeClr val="tx1"/>
-                </a:solidFill>
-              </a:rPr>
-              <a:t>Fuera del navegador</a:t>
-            </a:r>
-            <a:endParaRPr lang="en-US" sz="1600" dirty="0"/>
-          </a:p>
-          <a:p>
-            <a:pPr indent="0" marL="0">
-              <a:buNone/>
-            </a:pPr>
-            <a:r>
-              <a:rPr lang="en-US" sz="1400" dirty="0">
-                <a:solidFill>
-                  <a:schemeClr val="accent6"/>
-                </a:solidFill>
-              </a:rPr>
-              <a:t>No controla PowerPoint o Keynote de escritorio ni relojes inteligentes.</a:t>
-            </a:r>
-            <a:endParaRPr lang="en-US" sz="1600" dirty="0"/>
-          </a:p>
-        </p:txBody>
-      </p:sp>
-      <p:sp>
-        <p:nvSpPr>
-          <p:cNvPr id="14" name="proximos"/>
-          <p:cNvSpPr txBox="1"/>
-          <p:nvPr/>
-        </p:nvSpPr>
-        <p:spPr>
-          <a:xfrm>
-            <a:off x="6251296" y="2011680"/>
-            <a:ext cx="5300320" cy="502920"/>
-          </a:xfrm>
-          <a:prstGeom prst="rect">
-            <a:avLst/>
-          </a:prstGeom>
-          <a:noFill/>
-          <a:ln/>
-        </p:spPr>
-        <p:txBody>
-          <a:bodyPr wrap="square" lIns="0" tIns="0" rIns="0" bIns="0" rtlCol="0" anchor="ctr"/>
-          <a:lstStyle/>
-          <a:p>
-            <a:pPr indent="0" marL="0">
-              <a:buNone/>
-            </a:pPr>
-            <a:r>
-              <a:rPr lang="en-US" sz="1800" b="1" dirty="0">
-                <a:solidFill>
-                  <a:schemeClr val="tx1"/>
-                </a:solidFill>
-              </a:rPr>
-              <a:t>Avances y próximos pasos</a:t>
-            </a:r>
-            <a:endParaRPr lang="en-US" sz="1800" dirty="0"/>
-          </a:p>
-        </p:txBody>
-      </p:sp>
-      <p:sp>
-        <p:nvSpPr>
-          <p:cNvPr id="15" name="icono-fondo-204"/>
-          <p:cNvSpPr/>
-          <p:nvPr/>
-        </p:nvSpPr>
-        <p:spPr>
-          <a:xfrm>
-            <a:off x="6251296" y="2743200"/>
-            <a:ext cx="502920" cy="502920"/>
-          </a:xfrm>
-          <a:prstGeom prst="roundRect">
-            <a:avLst>
-              <a:gd name="adj" fmla="val 26000"/>
-            </a:avLst>
           </a:prstGeom>
           <a:solidFill>
             <a:schemeClr val="accent2"/>
@@ -5925,7 +5796,7 @@
       </p:sp>
       <p:pic>
         <p:nvPicPr>
-          <p:cNvPr id="16" name="icono-LuCircleCheck-205" descr="preencoded.png">    </p:cNvPr>
+          <p:cNvPr id="10" name="hecho-icono-202" descr="preencoded.png">    </p:cNvPr>
           <p:cNvPicPr>
             <a:picLocks noChangeAspect="1"/>
           </p:cNvPicPr>
@@ -5939,8 +5810,8 @@
         </p:blipFill>
         <p:spPr>
           <a:xfrm>
-            <a:off x="6371996" y="2863901"/>
-            <a:ext cx="261518" cy="261518"/>
+            <a:off x="1042416" y="3392424"/>
+            <a:ext cx="237744" cy="237744"/>
           </a:xfrm>
           <a:prstGeom prst="rect">
             <a:avLst/>
@@ -5949,14 +5820,14 @@
       </p:pic>
       <p:sp>
         <p:nvSpPr>
-          <p:cNvPr id="17" name="texto-206"/>
+          <p:cNvPr id="11" name="texto-203"/>
           <p:cNvSpPr txBox="1"/>
           <p:nvPr/>
         </p:nvSpPr>
         <p:spPr>
           <a:xfrm>
-            <a:off x="6982816" y="2706624"/>
-            <a:ext cx="4568800" cy="777240"/>
+            <a:off x="1536192" y="3273552"/>
+            <a:ext cx="4111600" cy="713232"/>
           </a:xfrm>
           <a:prstGeom prst="rect">
             <a:avLst/>
@@ -5975,46 +5846,44 @@
               <a:buNone/>
             </a:pPr>
             <a:r>
-              <a:rPr lang="en-US" sz="1600" b="1" dirty="0">
+              <a:rPr lang="en-US" sz="1500" b="1" dirty="0">
                 <a:solidFill>
                   <a:schemeClr val="tx1"/>
                 </a:solidFill>
               </a:rPr>
-              <a:t>Retransmisión con Cloudflare · lista</a:t>
-            </a:r>
-            <a:endParaRPr lang="en-US" sz="1600" dirty="0"/>
-          </a:p>
-          <a:p>
-            <a:pPr indent="0" marL="0">
-              <a:buNone/>
-            </a:pPr>
-            <a:r>
-              <a:rPr lang="en-US" sz="1400" dirty="0">
+              <a:t>Protección de costos</a:t>
+            </a:r>
+            <a:endParaRPr lang="en-US" sz="1500" dirty="0"/>
+          </a:p>
+          <a:p>
+            <a:pPr indent="0" marL="0">
+              <a:buNone/>
+            </a:pPr>
+            <a:r>
+              <a:rPr lang="en-US" sz="1300" dirty="0">
                 <a:solidFill>
                   <a:schemeClr val="accent6"/>
                 </a:solidFill>
               </a:rPr>
-              <a:t>Funciona en redes restrictivas; gratis hasta 1.000 GB al mes.</a:t>
-            </a:r>
-            <a:endParaRPr lang="en-US" sz="1600" dirty="0"/>
-          </a:p>
-        </p:txBody>
-      </p:sp>
-      <p:sp>
-        <p:nvSpPr>
-          <p:cNvPr id="18" name="icono-fondo-207"/>
-          <p:cNvSpPr/>
-          <p:nvPr/>
-        </p:nvSpPr>
-        <p:spPr>
-          <a:xfrm>
-            <a:off x="6251296" y="3584448"/>
-            <a:ext cx="502920" cy="502920"/>
-          </a:xfrm>
-          <a:prstGeom prst="roundRect">
-            <a:avLst>
-              <a:gd name="adj" fmla="val 26000"/>
-            </a:avLst>
+              <a:t>Se pausa sola a los 900 GB del mes y se reactiva cada mes.</a:t>
+            </a:r>
+            <a:endParaRPr lang="en-US" sz="1500" dirty="0"/>
+          </a:p>
+        </p:txBody>
+      </p:sp>
+      <p:sp>
+        <p:nvSpPr>
+          <p:cNvPr id="12" name="hecho-204"/>
+          <p:cNvSpPr/>
+          <p:nvPr/>
+        </p:nvSpPr>
+        <p:spPr>
+          <a:xfrm>
+            <a:off x="960120" y="4041648"/>
+            <a:ext cx="402336" cy="402336"/>
+          </a:xfrm>
+          <a:prstGeom prst="ellipse">
+            <a:avLst/>
           </a:prstGeom>
           <a:solidFill>
             <a:schemeClr val="accent2"/>
@@ -6024,7 +5893,7 @@
       </p:sp>
       <p:pic>
         <p:nvPicPr>
-          <p:cNvPr id="19" name="icono-LuCircleCheck-208" descr="preencoded.png">    </p:cNvPr>
+          <p:cNvPr id="13" name="hecho-icono-205" descr="preencoded.png">    </p:cNvPr>
           <p:cNvPicPr>
             <a:picLocks noChangeAspect="1"/>
           </p:cNvPicPr>
@@ -6038,8 +5907,8 @@
         </p:blipFill>
         <p:spPr>
           <a:xfrm>
-            <a:off x="6371996" y="3705149"/>
-            <a:ext cx="261518" cy="261518"/>
+            <a:off x="1042416" y="4123944"/>
+            <a:ext cx="237744" cy="237744"/>
           </a:xfrm>
           <a:prstGeom prst="rect">
             <a:avLst/>
@@ -6048,14 +5917,14 @@
       </p:pic>
       <p:sp>
         <p:nvSpPr>
-          <p:cNvPr id="20" name="texto-209"/>
+          <p:cNvPr id="14" name="texto-206"/>
           <p:cNvSpPr txBox="1"/>
           <p:nvPr/>
         </p:nvSpPr>
         <p:spPr>
           <a:xfrm>
-            <a:off x="6982816" y="3547872"/>
-            <a:ext cx="4568800" cy="777240"/>
+            <a:off x="1536192" y="4005072"/>
+            <a:ext cx="4111600" cy="713232"/>
           </a:xfrm>
           <a:prstGeom prst="rect">
             <a:avLst/>
@@ -6074,56 +5943,54 @@
               <a:buNone/>
             </a:pPr>
             <a:r>
-              <a:rPr lang="en-US" sz="1600" b="1" dirty="0">
+              <a:rPr lang="en-US" sz="1500" b="1" dirty="0">
                 <a:solidFill>
                   <a:schemeClr val="tx1"/>
                 </a:solidFill>
               </a:rPr>
-              <a:t>QR nuevo en cada sesión · listo</a:t>
-            </a:r>
-            <a:endParaRPr lang="en-US" sz="1600" dirty="0"/>
-          </a:p>
-          <a:p>
-            <a:pPr indent="0" marL="0">
-              <a:buNone/>
-            </a:pPr>
-            <a:r>
-              <a:rPr lang="en-US" sz="1400" dirty="0">
+              <a:t>Código QR nuevo en cada sesión</a:t>
+            </a:r>
+            <a:endParaRPr lang="en-US" sz="1500" dirty="0"/>
+          </a:p>
+          <a:p>
+            <a:pPr indent="0" marL="0">
+              <a:buNone/>
+            </a:pPr>
+            <a:r>
+              <a:rPr lang="en-US" sz="1300" dirty="0">
                 <a:solidFill>
                   <a:schemeClr val="accent6"/>
                 </a:solidFill>
               </a:rPr>
-              <a:t>Activado por defecto; se puede desactivar en Ajustes.</a:t>
-            </a:r>
-            <a:endParaRPr lang="en-US" sz="1600" dirty="0"/>
-          </a:p>
-        </p:txBody>
-      </p:sp>
-      <p:sp>
-        <p:nvSpPr>
-          <p:cNvPr id="21" name="icono-fondo-210"/>
-          <p:cNvSpPr/>
-          <p:nvPr/>
-        </p:nvSpPr>
-        <p:spPr>
-          <a:xfrm>
-            <a:off x="6251296" y="4425696"/>
-            <a:ext cx="502920" cy="502920"/>
-          </a:xfrm>
-          <a:prstGeom prst="roundRect">
-            <a:avLst>
-              <a:gd name="adj" fmla="val 26000"/>
-            </a:avLst>
+              <a:t>Activado por defecto; se puede cambiar en Ajustes.</a:t>
+            </a:r>
+            <a:endParaRPr lang="en-US" sz="1500" dirty="0"/>
+          </a:p>
+        </p:txBody>
+      </p:sp>
+      <p:sp>
+        <p:nvSpPr>
+          <p:cNvPr id="15" name="hecho-207"/>
+          <p:cNvSpPr/>
+          <p:nvPr/>
+        </p:nvSpPr>
+        <p:spPr>
+          <a:xfrm>
+            <a:off x="960120" y="4773168"/>
+            <a:ext cx="402336" cy="402336"/>
+          </a:xfrm>
+          <a:prstGeom prst="ellipse">
+            <a:avLst/>
           </a:prstGeom>
           <a:solidFill>
-            <a:schemeClr val="accent1"/>
+            <a:schemeClr val="accent2"/>
           </a:solidFill>
           <a:ln/>
         </p:spPr>
       </p:sp>
       <p:pic>
         <p:nvPicPr>
-          <p:cNvPr id="22" name="icono-LuHourglass-211" descr="preencoded.png">    </p:cNvPr>
+          <p:cNvPr id="16" name="hecho-icono-208" descr="preencoded.png">    </p:cNvPr>
           <p:cNvPicPr>
             <a:picLocks noChangeAspect="1"/>
           </p:cNvPicPr>
@@ -6137,8 +6004,8 @@
         </p:blipFill>
         <p:spPr>
           <a:xfrm>
-            <a:off x="6371996" y="4546397"/>
-            <a:ext cx="261518" cy="261518"/>
+            <a:off x="1042416" y="4855464"/>
+            <a:ext cx="237744" cy="237744"/>
           </a:xfrm>
           <a:prstGeom prst="rect">
             <a:avLst/>
@@ -6147,14 +6014,14 @@
       </p:pic>
       <p:sp>
         <p:nvSpPr>
-          <p:cNvPr id="23" name="texto-212"/>
+          <p:cNvPr id="17" name="texto-209"/>
           <p:cNvSpPr txBox="1"/>
           <p:nvPr/>
         </p:nvSpPr>
         <p:spPr>
           <a:xfrm>
-            <a:off x="6982816" y="4389120"/>
-            <a:ext cx="4568800" cy="777240"/>
+            <a:off x="1536192" y="4736592"/>
+            <a:ext cx="4111600" cy="713232"/>
           </a:xfrm>
           <a:prstGeom prst="rect">
             <a:avLst/>
@@ -6173,40 +6040,76 @@
               <a:buNone/>
             </a:pPr>
             <a:r>
-              <a:rPr lang="en-US" sz="1600" b="1" dirty="0">
+              <a:rPr lang="en-US" sz="1500" b="1" dirty="0">
                 <a:solidFill>
                   <a:schemeClr val="tx1"/>
                 </a:solidFill>
               </a:rPr>
-              <a:t>Chrome Web Store</a:t>
-            </a:r>
-            <a:endParaRPr lang="en-US" sz="1600" dirty="0"/>
-          </a:p>
-          <a:p>
-            <a:pPr indent="0" marL="0">
-              <a:buNone/>
-            </a:pPr>
-            <a:r>
-              <a:rPr lang="en-US" sz="1400" dirty="0">
+              <a:t>Control web publicado</a:t>
+            </a:r>
+            <a:endParaRPr lang="en-US" sz="1500" dirty="0"/>
+          </a:p>
+          <a:p>
+            <a:pPr indent="0" marL="0">
+              <a:buNone/>
+            </a:pPr>
+            <a:r>
+              <a:rPr lang="en-US" sz="1300" dirty="0">
                 <a:solidFill>
                   <a:schemeClr val="accent6"/>
                 </a:solidFill>
               </a:rPr>
-              <a:t>La versión 1.0 está en revisión; la 1.1 ya está preparada.</a:t>
-            </a:r>
-            <a:endParaRPr lang="en-US" sz="1600" dirty="0"/>
-          </a:p>
-        </p:txBody>
-      </p:sp>
-      <p:sp>
-        <p:nvSpPr>
-          <p:cNvPr id="24" name="icono-fondo-213"/>
-          <p:cNvSpPr/>
-          <p:nvPr/>
-        </p:nvSpPr>
-        <p:spPr>
-          <a:xfrm>
-            <a:off x="6251296" y="5266944"/>
+              <a:t>En GitHub Pages, con reconexión automática.</a:t>
+            </a:r>
+            <a:endParaRPr lang="en-US" sz="1500" dirty="0"/>
+          </a:p>
+        </p:txBody>
+      </p:sp>
+      <p:sp>
+        <p:nvSpPr>
+          <p:cNvPr id="18" name="sigue"/>
+          <p:cNvSpPr txBox="1"/>
+          <p:nvPr/>
+        </p:nvSpPr>
+        <p:spPr>
+          <a:xfrm>
+            <a:off x="6251296" y="1965960"/>
+            <a:ext cx="5300320" cy="457200"/>
+          </a:xfrm>
+          <a:prstGeom prst="rect">
+            <a:avLst/>
+          </a:prstGeom>
+          <a:noFill/>
+          <a:ln/>
+        </p:spPr>
+        <p:txBody>
+          <a:bodyPr wrap="square" lIns="0" tIns="0" rIns="0" bIns="0" rtlCol="0" anchor="ctr"/>
+          <a:lstStyle/>
+          <a:p>
+            <a:pPr indent="0" marL="0">
+              <a:buNone/>
+            </a:pPr>
+            <a:r>
+              <a:rPr lang="en-US" sz="1800" b="1" dirty="0">
+                <a:solidFill>
+                  <a:schemeClr val="tx1"/>
+                </a:solidFill>
+              </a:rPr>
+              <a:t>Lo que sigue</a:t>
+            </a:r>
+            <a:endParaRPr lang="en-US" sz="1800" dirty="0"/>
+          </a:p>
+        </p:txBody>
+      </p:sp>
+      <p:sp>
+        <p:nvSpPr>
+          <p:cNvPr id="19" name="icono-fondo-210"/>
+          <p:cNvSpPr/>
+          <p:nvPr/>
+        </p:nvSpPr>
+        <p:spPr>
+          <a:xfrm>
+            <a:off x="6251296" y="2606040"/>
             <a:ext cx="502920" cy="502920"/>
           </a:xfrm>
           <a:prstGeom prst="roundRect">
@@ -6222,7 +6125,7 @@
       </p:sp>
       <p:pic>
         <p:nvPicPr>
-          <p:cNvPr id="25" name="icono-LuWatch-214" descr="preencoded.png">    </p:cNvPr>
+          <p:cNvPr id="20" name="icono-LuHourglass-211" descr="preencoded.png">    </p:cNvPr>
           <p:cNvPicPr>
             <a:picLocks noChangeAspect="1"/>
           </p:cNvPicPr>
@@ -6236,7 +6139,7 @@
         </p:blipFill>
         <p:spPr>
           <a:xfrm>
-            <a:off x="6371996" y="5387645"/>
+            <a:off x="6371996" y="2726741"/>
             <a:ext cx="261518" cy="261518"/>
           </a:xfrm>
           <a:prstGeom prst="rect">
@@ -6246,14 +6149,14 @@
       </p:pic>
       <p:sp>
         <p:nvSpPr>
-          <p:cNvPr id="26" name="texto-215"/>
+          <p:cNvPr id="21" name="texto-212"/>
           <p:cNvSpPr txBox="1"/>
           <p:nvPr/>
         </p:nvSpPr>
         <p:spPr>
           <a:xfrm>
-            <a:off x="6982816" y="5230368"/>
-            <a:ext cx="4568800" cy="777240"/>
+            <a:off x="6982816" y="2569464"/>
+            <a:ext cx="4568800" cy="1051560"/>
           </a:xfrm>
           <a:prstGeom prst="rect">
             <a:avLst/>
@@ -6277,6 +6180,105 @@
                   <a:schemeClr val="tx1"/>
                 </a:solidFill>
               </a:rPr>
+              <a:t>Chrome Web Store</a:t>
+            </a:r>
+            <a:endParaRPr lang="en-US" sz="1600" dirty="0"/>
+          </a:p>
+          <a:p>
+            <a:pPr indent="0" marL="0">
+              <a:buNone/>
+            </a:pPr>
+            <a:r>
+              <a:rPr lang="en-US" sz="1400" dirty="0">
+                <a:solidFill>
+                  <a:schemeClr val="accent6"/>
+                </a:solidFill>
+              </a:rPr>
+              <a:t>La versión 1.0 («Mando») está en revisión. Al aprobarse, se sube la 1.1 con el nombre Presentazo.</a:t>
+            </a:r>
+            <a:endParaRPr lang="en-US" sz="1600" dirty="0"/>
+          </a:p>
+        </p:txBody>
+      </p:sp>
+      <p:sp>
+        <p:nvSpPr>
+          <p:cNvPr id="22" name="icono-fondo-213"/>
+          <p:cNvSpPr/>
+          <p:nvPr/>
+        </p:nvSpPr>
+        <p:spPr>
+          <a:xfrm>
+            <a:off x="6251296" y="3794760"/>
+            <a:ext cx="502920" cy="502920"/>
+          </a:xfrm>
+          <a:prstGeom prst="roundRect">
+            <a:avLst>
+              <a:gd name="adj" fmla="val 26000"/>
+            </a:avLst>
+          </a:prstGeom>
+          <a:solidFill>
+            <a:schemeClr val="accent1"/>
+          </a:solidFill>
+          <a:ln/>
+        </p:spPr>
+      </p:sp>
+      <p:pic>
+        <p:nvPicPr>
+          <p:cNvPr id="23" name="icono-LuWatch-214" descr="preencoded.png">    </p:cNvPr>
+          <p:cNvPicPr>
+            <a:picLocks noChangeAspect="1"/>
+          </p:cNvPicPr>
+          <p:nvPr/>
+        </p:nvPicPr>
+        <p:blipFill>
+          <a:blip r:embed="rId6"/>
+          <a:stretch>
+            <a:fillRect/>
+          </a:stretch>
+        </p:blipFill>
+        <p:spPr>
+          <a:xfrm>
+            <a:off x="6371996" y="3915461"/>
+            <a:ext cx="261518" cy="261518"/>
+          </a:xfrm>
+          <a:prstGeom prst="rect">
+            <a:avLst/>
+          </a:prstGeom>
+        </p:spPr>
+      </p:pic>
+      <p:sp>
+        <p:nvSpPr>
+          <p:cNvPr id="24" name="texto-215"/>
+          <p:cNvSpPr txBox="1"/>
+          <p:nvPr/>
+        </p:nvSpPr>
+        <p:spPr>
+          <a:xfrm>
+            <a:off x="6982816" y="3758184"/>
+            <a:ext cx="4568800" cy="1051560"/>
+          </a:xfrm>
+          <a:prstGeom prst="rect">
+            <a:avLst/>
+          </a:prstGeom>
+          <a:noFill/>
+          <a:ln/>
+        </p:spPr>
+        <p:txBody>
+          <a:bodyPr wrap="square" lIns="0" tIns="0" rIns="0" bIns="0" rtlCol="0" anchor="t"/>
+          <a:lstStyle/>
+          <a:p>
+            <a:pPr indent="0" marL="0">
+              <a:spcAft>
+                <a:spcPts val="300"/>
+              </a:spcAft>
+              <a:buNone/>
+            </a:pPr>
+            <a:r>
+              <a:rPr lang="en-US" sz="1600" b="1" dirty="0">
+                <a:solidFill>
+                  <a:schemeClr val="tx1"/>
+                </a:solidFill>
+              </a:rPr>
               <a:t>App para Apple Watch</a:t>
             </a:r>
             <a:endParaRPr lang="en-US" sz="1600" dirty="0"/>
@@ -6294,6 +6296,77 @@
               <a:t>Evaluar una app nativa que use el iPhone como puente.</a:t>
             </a:r>
             <a:endParaRPr lang="en-US" sz="1600" dirty="0"/>
+          </a:p>
+        </p:txBody>
+      </p:sp>
+      <p:pic>
+        <p:nvPicPr>
+          <p:cNvPr id="25" name="limites-icono" descr="preencoded.png">    </p:cNvPr>
+          <p:cNvPicPr>
+            <a:picLocks noChangeAspect="1"/>
+          </p:cNvPicPr>
+          <p:nvPr/>
+        </p:nvPicPr>
+        <p:blipFill>
+          <a:blip r:embed="rId7"/>
+          <a:stretch>
+            <a:fillRect/>
+          </a:stretch>
+        </p:blipFill>
+        <p:spPr>
+          <a:xfrm>
+            <a:off x="640080" y="5788152"/>
+            <a:ext cx="256032" cy="256032"/>
+          </a:xfrm>
+          <a:prstGeom prst="rect">
+            <a:avLst/>
+          </a:prstGeom>
+        </p:spPr>
+      </p:pic>
+      <p:sp>
+        <p:nvSpPr>
+          <p:cNvPr id="26" name="limites"/>
+          <p:cNvSpPr txBox="1"/>
+          <p:nvPr/>
+        </p:nvSpPr>
+        <p:spPr>
+          <a:xfrm>
+            <a:off x="1024128" y="5715000"/>
+            <a:ext cx="10527487" cy="411480"/>
+          </a:xfrm>
+          <a:prstGeom prst="rect">
+            <a:avLst/>
+          </a:prstGeom>
+          <a:noFill/>
+          <a:ln/>
+        </p:spPr>
+        <p:txBody>
+          <a:bodyPr wrap="square" lIns="0" tIns="0" rIns="0" bIns="0" rtlCol="0" anchor="ctr"/>
+          <a:lstStyle/>
+          <a:p>
+            <a:pPr indent="0" marL="0">
+              <a:buNone/>
+            </a:pPr>
+            <a:r>
+              <a:rPr lang="en-US" sz="1300" b="1" dirty="0">
+                <a:solidFill>
+                  <a:schemeClr val="tx1"/>
+                </a:solidFill>
+              </a:rPr>
+              <a:t>Límites que se mantienen: </a:t>
+            </a:r>
+            <a:pPr indent="0" marL="0">
+              <a:buNone/>
+            </a:pPr>
+            <a:r>
+              <a:rPr lang="en-US" sz="1300" dirty="0">
+                <a:solidFill>
+                  <a:schemeClr val="accent6"/>
+                </a:solidFill>
+              </a:rPr>
+              <a:t>necesita internet para enlazar los dispositivos y no funciona en páginas internas de Chrome ni fuera del navegador.</a:t>
+            </a:r>
+            <a:endParaRPr lang="en-US" sz="1300" dirty="0"/>
           </a:p>
         </p:txBody>
       </p:sp>
@@ -6369,7 +6442,7 @@
       </p:grpSpPr>
       <p:pic>
         <p:nvPicPr>
-          <p:cNvPr id="2" name="logo-cierre" descr="Logo de Mando">    </p:cNvPr>
+          <p:cNvPr id="2" name="logo-cierre" descr="Logo de Presentazo">    </p:cNvPr>
           <p:cNvPicPr>
             <a:picLocks noChangeAspect="1"/>
           </p:cNvPicPr>
@@ -6671,7 +6744,7 @@
       </p:sp>
       <p:pic>
         <p:nvPicPr>
-          <p:cNvPr id="12" name="qr" descr="Código QR al repositorio de Mando en GitHub">    </p:cNvPr>
+          <p:cNvPr id="12" name="qr" descr="Código QR al repositorio de Presentazo en GitHub">    </p:cNvPr>
           <p:cNvPicPr>
             <a:picLocks noChangeAspect="1"/>
           </p:cNvPicPr>
@@ -6756,7 +6829,7 @@
       </p:grpSpPr>
       <p:pic>
         <p:nvPicPr>
-          <p:cNvPr id="2" name="logo-final" descr="Logo de Mando">    </p:cNvPr>
+          <p:cNvPr id="2" name="logo-final" descr="Logo de Presentazo">    </p:cNvPr>
           <p:cNvPicPr>
             <a:picLocks noChangeAspect="1"/>
           </p:cNvPicPr>
@@ -6789,7 +6862,7 @@
         <p:spPr>
           <a:xfrm>
             <a:off x="822960" y="2788920"/>
-            <a:ext cx="4937760" cy="1051560"/>
+            <a:ext cx="5257800" cy="1051560"/>
           </a:xfrm>
           <a:prstGeom prst="rect">
             <a:avLst/>
@@ -6805,14 +6878,14 @@
               <a:buNone/>
             </a:pPr>
             <a:r>
-              <a:rPr lang="en-US" sz="6600" b="1" dirty="0">
+              <a:rPr lang="en-US" sz="6000" b="1" dirty="0">
                 <a:solidFill>
                   <a:schemeClr val="bg1"/>
                 </a:solidFill>
               </a:rPr>
               <a:t>Gracias</a:t>
             </a:r>
-            <a:endParaRPr lang="en-US" sz="6600" dirty="0"/>
+            <a:endParaRPr lang="en-US" sz="6000" dirty="0"/>
           </a:p>
         </p:txBody>
       </p:sp>
@@ -6919,7 +6992,7 @@
       </p:sp>
       <p:pic>
         <p:nvPicPr>
-          <p:cNvPr id="7" name="captura-223" descr="Diapositiva con anotaciones del lápiz de Mando">    </p:cNvPr>
+          <p:cNvPr id="7" name="captura-223" descr="Diapositiva con anotaciones del lápiz de Presentazo">    </p:cNvPr>
           <p:cNvPicPr>
             <a:picLocks noChangeAspect="1"/>
           </p:cNvPicPr>
@@ -7622,7 +7695,7 @@
                   <a:schemeClr val="bg1"/>
                 </a:solidFill>
               </a:rPr>
-              <a:t>Con Mando, todo eso se resuelve desde el celular que ya llevas en el bolsillo.</a:t>
+              <a:t>Con Presentazo, todo eso se resuelve desde el celular que ya llevas en el bolsillo.</a:t>
             </a:r>
             <a:endParaRPr lang="en-US" sz="1700" dirty="0"/>
           </a:p>
@@ -7768,7 +7841,7 @@
                   <a:schemeClr val="tx1"/>
                 </a:solidFill>
               </a:rPr>
-              <a:t>Mando convierte tu celular en el control remoto</a:t>
+              <a:t>Tu celular, convertido en control remoto</a:t>
             </a:r>
             <a:endParaRPr lang="en-US" sz="3600" dirty="0"/>
           </a:p>
@@ -8624,7 +8697,7 @@
       </p:sp>
       <p:pic>
         <p:nvPicPr>
-          <p:cNvPr id="13" name="captura-42" descr="Código QR de Mando">    </p:cNvPr>
+          <p:cNvPr id="13" name="captura-42" descr="Código QR de Presentazo">    </p:cNvPr>
           <p:cNvPicPr>
             <a:picLocks noChangeAspect="1"/>
           </p:cNvPicPr>
@@ -8749,7 +8822,7 @@
                   <a:schemeClr val="accent6"/>
                 </a:solidFill>
               </a:rPr>
-              <a:t>Haz clic en el ícono de Mando (Alt+Shift+M) y apunta la cámara al QR.</a:t>
+              <a:t>Haz clic en el ícono de Presentazo (Alt+Shift+M) y apunta la cámara al QR.</a:t>
             </a:r>
             <a:endParaRPr lang="en-US" sz="1800" dirty="0"/>
           </a:p>
@@ -10640,7 +10713,7 @@
                   <a:schemeClr val="tx1"/>
                 </a:solidFill>
               </a:rPr>
-              <a:t>Por qué usar Mando</a:t>
+              <a:t>Por qué usar Presentazo</a:t>
             </a:r>
             <a:endParaRPr lang="en-US" sz="3600" dirty="0"/>
           </a:p>
@@ -12697,9 +12770,9 @@
 </file>
 
 <file path=ppt/theme/theme1.xml><?xml version="1.0" encoding="utf-8"?>
-<a:theme xmlns:a="http://schemas.openxmlformats.org/drawingml/2006/main" name="Mando">
+<a:theme xmlns:a="http://schemas.openxmlformats.org/drawingml/2006/main" name="Presentazo">
   <a:themeElements>
-    <a:clrScheme name="Mando">
+    <a:clrScheme name="Presentazo">
       <a:dk1>
         <a:srgbClr val="0B0B0C"/>
       </a:dk1>
@@ -12737,7 +12810,7 @@
         <a:srgbClr val="8E8E93"/>
       </a:folHlink>
     </a:clrScheme>
-    <a:fontScheme name="Mando">
+    <a:fontScheme name="Presentazo">
       <a:majorFont>
         <a:latin typeface="Arial"/>
         <a:ea typeface=""/>

</xml_diff>

<commit_message>
Permisos mínimos: activeTab en lugar de acceso a todos los sitios
Responde al aviso de la Chrome Web Store sobre «permisos generales de host»:

- La extensión pide activeTab y actúa solo en la pestaña donde se pulsa
  su ícono. Ya no muestra al instalarse «Leer y cambiar todos tus datos».
- El acceso a todos los sitios pasa a optional_host_permissions: se pide con
  un clic solo para «Seguir la pestaña activa», y por sitio para
  presentaciones incrustadas (p. ej. PowerPoint para la web). Ajustes
  permite darlo o quitarlo.
- Si la pestaña cambia de sitio, el celular indica que hay que volver a
  pulsar el ícono; al hacerlo, la extensión recupera el control sola.
- Prueba de punta a punta en dos modos: activeTab (43 comprobaciones) y con
  el acceso opcional concedido (42). Google Slides verificado sin permisos
  de sitios.
- Ficha de la tienda, política de privacidad, README, registro de cambios y
  presentación actualizados.

Co-Authored-By: Claude Opus 5.5 <noreply@anthropic.com>
</commit_message>
<xml_diff>
--- a/presentacion/mando.pptx
+++ b/presentacion/mando.pptx
@@ -121,7 +121,7 @@
   <p:extLst>
     <p:ext uri="{521415D9-36F7-43E2-AB2F-B90AF26B5E84}">
       <p14:sectionLst xmlns:p14="http://schemas.microsoft.com/office/powerpoint/2010/main">
-        <p14:section name="Introducción" id="{95793fad-9825-39e2-ec6e-f81686b1b5fd}">
+        <p14:section name="Introducción" id="{30cef092-71b7-9727-4a13-42ebe84e97a1}">
           <p14:sldIdLst>
             <p14:sldId id="256"/>
             <p14:sldId id="257"/>
@@ -129,27 +129,27 @@
             <p14:sldId id="259"/>
           </p14:sldIdLst>
         </p14:section>
-        <p14:section name="Funciones" id="{4de36e3f-f06f-2548-7027-682465533058}">
+        <p14:section name="Funciones" id="{990aedf9-e937-103b-d5a9-45890a4f7e4e}">
           <p14:sldIdLst>
             <p14:sldId id="260"/>
             <p14:sldId id="261"/>
             <p14:sldId id="262"/>
           </p14:sldIdLst>
         </p14:section>
-        <p14:section name="Valor" id="{f17600f2-e6ee-45ea-2607-614e9a65286c}">
+        <p14:section name="Valor" id="{4972cc06-44b0-7d43-5822-b2b1f7470bc1}">
           <p14:sldIdLst>
             <p14:sldId id="263"/>
             <p14:sldId id="264"/>
           </p14:sldIdLst>
         </p14:section>
-        <p14:section name="Tecnología" id="{79f2e2a7-ea93-2022-43e2-16701c791e30}">
+        <p14:section name="Tecnología" id="{804d7d24-5919-ce37-96fd-3497354004b4}">
           <p14:sldIdLst>
             <p14:sldId id="265"/>
             <p14:sldId id="266"/>
             <p14:sldId id="267"/>
           </p14:sldIdLst>
         </p14:section>
-        <p14:section name="Cierre" id="{2a9e87be-c8fc-523e-ffd4-48945e44dbb5}">
+        <p14:section name="Cierre" id="{790004ac-1d7d-f751-b4b9-5b89356271c2}">
           <p14:sldIdLst>
             <p14:sldId id="268"/>
             <p14:sldId id="269"/>
@@ -736,7 +736,7 @@
           <a:p>
             <a:r>
               <a:rPr lang="en-US" dirty="0"/>
-              <a:t>La seguridad está en el diseño: conexión cifrada de extremo a extremo, la clave secreta solo existe en el QR, los scripts solo están activos mientras hay una sesión, no hay cuentas ni recopilación de datos y un botón permite renovar el código en cualquier momento.</a:t>
+              <a:t>La seguridad está en el diseño: conexión cifrada de extremo a extremo, la clave secreta solo existe en el QR, Presentazo solo actúa en la pestaña donde se pulsa su ícono y no pide acceso a todos los sitios, no hay cuentas ni recopilación de datos y un botón permite renovar el código en cualquier momento.</a:t>
             </a:r>
             <a:endParaRPr lang="en-US" dirty="0"/>
           </a:p>
@@ -4235,7 +4235,7 @@
       </p:sp>
       <p:pic>
         <p:nvPicPr>
-          <p:cNvPr id="8" name="icono-LuPower-168" descr="preencoded.png">    </p:cNvPr>
+          <p:cNvPr id="8" name="icono-LuMousePointerClick-168" descr="preencoded.png">    </p:cNvPr>
           <p:cNvPicPr>
             <a:picLocks noChangeAspect="1"/>
           </p:cNvPicPr>
@@ -4290,7 +4290,7 @@
                   <a:schemeClr val="bg1"/>
                 </a:solidFill>
               </a:rPr>
-              <a:t>Activo solo durante la sesión</a:t>
+              <a:t>Solo la pestaña que eliges</a:t>
             </a:r>
             <a:endParaRPr lang="en-US" sz="1700" dirty="0"/>
           </a:p>
@@ -4304,7 +4304,7 @@
                   <a:schemeClr val="accent5"/>
                 </a:solidFill>
               </a:rPr>
-              <a:t>Los scripts de Presentazo se retiran de Chrome al detener la sesión.</a:t>
+              <a:t>Actúa únicamente donde pulsas su ícono; no pide acceso a todos tus sitios.</a:t>
             </a:r>
             <a:endParaRPr lang="en-US" sz="1700" dirty="0"/>
           </a:p>

</xml_diff>